<commit_message>
Rückmeldung 28.10.: Schriftgröße 27, Eingangsfrage ohne Fachbegriff, präzise Beurteilen-Frage, Berater-Frage mit Risiko (8C Stunde 2, 8D Folien, Sequenz, CLAUDE.md)
Co-Authored-By: Claude Sonnet 5.5 <noreply@anthropic.com>
Claude-Session: https://claude.ai/code/session_01GXwmzpsaCraifErTDddPwN
</commit_message>
<xml_diff>
--- a/Geschichte_8/Stunde2_Nationalversammlung/Praesentation_Stunde2_Nationalversammlung.pptx
+++ b/Geschichte_8/Stunde2_Nationalversammlung/Praesentation_Stunde2_Nationalversammlung.pptx
@@ -518,7 +518,7 @@
           <a:p>
             <a:r>
               <a:rPr lang="en-US" dirty="0"/>
-              <a:t>Die Folie steht beim Betreten. Niemand muss etwas sagen. Die zwei Sätze zu „Was ist eine Revolution? Gut oder schlecht? Warum?“ bleiben im Heft (Eingangsdiagnose, Vergleich in Stunde 11). Lehrkraft 2 hospitiert nur. Ansage: „Stifte liegen. Ihr hört nur zu.“ Danach Folie 2 und 3.</a:t>
+              <a:t>Die Folie steht beim Betreten. Niemand muss etwas sagen. Die Meinung zu „Darf sich das Volk gegen einen König wehren, der allein regiert?“ bleibt im Heft (Eingangsdiagnose ohne Fachbegriff, weil die Klasse „Revolution“ noch nicht kennt; Vergleich in Stunde 11). Es gibt keine richtige Antwort, geprüft wird nichts. Lehrkraft 2 hospitiert nur. Ansage: „Stifte liegen. Ihr hört nur zu.“ Danach Folie 2 und 3.</a:t>
             </a:r>
             <a:endParaRPr lang="en-US" dirty="0"/>
           </a:p>
@@ -870,7 +870,7 @@
           <a:p>
             <a:r>
               <a:rPr lang="en-US" dirty="0"/>
-              <a:t>Ansage: „Arbeitet zu zweit. Flüsterstufe. Die Aufgabe steht rechts.“ Partnerarbeit 7 Minuten, die Schnipsel mit dem Dreischritt liegen auf dem Tisch, die Hilfekarten (Stufe 1 bis 3) liegen am Pult und werden nur auf Nachfrage geholt. Lehrkraft geht durch die Reihen und liest bei 4 bis 6 Paaren mit (unbenotet). Bild: Nachkolorierter Kupferstich, Paris, 1789 (Lehrbuch S. 111, Q3). Bildtext: „Jeden Tag mitten auf dem Feld – in Hitze und Kälte – sieht man den armen Bauern – arbeitend das ganze Jahr über – um mit seiner Arbeit das Geld zu verdienen – und damit den Steuereintreiber zu bezahlen.“ Beischrift oben: „Ne pour la peine“ (Für die Mühsal geboren), unten: „L'Homme de Village“ (Der Mann des Dorfes). Schritt 3 hat einen Stern (*): Bei Zeitnot nur angeleitet gemeinsam.</a:t>
+              <a:t>Ansage: „Arbeitet zu zweit. Flüsterstufe. Die Aufgabe steht rechts.“ Partnerarbeit 7 Minuten, die Schnipsel mit dem Dreischritt liegen auf dem Tisch, die Hilfekarten (Stufe 1 bis 3) liegen am Pult und werden nur auf Nachfrage geholt. Lehrkraft geht durch die Reihen und liest bei 4 bis 6 Paaren mit (unbenotet). Bild: Nachkolorierter Kupferstich, Paris, 1789 (Lehrbuch S. 111, Q3). Bildtext: „Jeden Tag mitten auf dem Feld – in Hitze und Kälte – sieht man den armen Bauern – arbeitend das ganze Jahr über – um mit seiner Arbeit das Geld zu verdienen – und damit den Steuereintreiber zu bezahlen.“ Beischrift oben: „Ne pour la peine“ (Für die Mühsal geboren), unten: „L'Homme de Village“ (Der Mann des Dorfes). Schritt 3 hat einen Stern (*): Bei Zeitnot nur angeleitet gemeinsam. Beurteilen heißt hier: Stimmt das Bild mit dem überein, was wir über Steuern und Stände wissen, wo übertreibt es, was will der Zeichner erreichen?</a:t>
             </a:r>
             <a:endParaRPr lang="en-US" dirty="0"/>
           </a:p>
@@ -1046,7 +1046,7 @@
           <a:p>
             <a:r>
               <a:rPr lang="en-US" dirty="0"/>
-              <a:t>Ansage: „Stifte liegen. Ihr hört nur zu. Das ist die letzte Aufgabe. Jetzt arbeitet ihr allein. Die Aufgabe steht rechts.“ Zehn Sekunden denken, dann schreiben. Es gibt mehrere gute Antworten, geprüft wird die Begründung: eine Position, ein Sachargument aus der Stunde, ein „weil“. Erwartung (Auswahl, keine Musterlösung): BLEIBEN/SCHWÖREN: Sie vertreten fast alle Menschen (Sieyès: ALLES); nur gemeinsam sind sie stark; der König lehnt sonst weiter ab und alles bleibt beim Alten; ohne Verfassung kann der König weiter allein entscheiden. NACH HAUSE GEHEN: Der König hat den Saal gesperrt, Gefahr (Soldaten); Unruhe vermeiden; später neu verhandeln. Zwischenlösung (bleiben, aber verhandeln) ist begründbar. Form nach Verlauf: Blitzlicht (je eine Stimme „bleiben“, eine „nach Hause“, gezielt aufgerufen), schriftlich mit Vorlesen oder Berater-Duell zu zweit. Stichprobe: bei 4 bis 6 Heften mitlesen, nicht kommentieren (unbenotet). Die Figuren sind Zeichnungen, keine historischen Porträts.</a:t>
+              <a:t>Ansage: „Stifte liegen. Ihr hört nur zu. Das ist die letzte Aufgabe. Jetzt arbeitet ihr allein. Die Aufgabe steht rechts.“ Zehn Sekunden denken, dann schreiben. Es gibt mehrere gute Antworten, geprüft wird die Begründung: eine Position, ein Sachargument aus der Stunde, ein „weil“. Erwartung (Auswahl, keine Musterlösung): SCHWÖREN: Die Abgeordneten vertreten fast alle Menschen (Sieyès: ALLES); wenn alle schwören, kann der König nicht alle verhaften; wer jetzt nachgibt, dem bleibt alles beim Alten; ohne Verfassung entscheidet der König weiter allein; Hunger und Steuern der Menschen. NICHT SCHWÖREN: Die Familie ist in Gefahr; Gewalt vermeiden; allein ist man leicht zu verhaften; später verhandeln. Zwischenlösung (schwören, aber Familie in Sicherheit bringen) ist begründbar. Historisch schworen fast alle Abgeordneten. Das Risiko macht die Frage persönlich: Es steht etwas auf dem Spiel. Form nach Verlauf: Blitzlicht (je eine Stimme „schwören“, eine „nicht schwören“, gezielt aufgerufen), schriftlich mit Vorlesen oder Berater-Duell zu zweit. Stichprobe: bei 4 bis 6 Heften mitlesen, nicht kommentieren (unbenotet). Die Figuren sind Zeichnungen, keine historischen Porträts.</a:t>
             </a:r>
             <a:endParaRPr lang="en-US" dirty="0"/>
           </a:p>
@@ -2562,7 +2562,7 @@
               <a:buNone/>
             </a:pPr>
             <a:r>
-              <a:rPr lang="en-US" sz="2400" dirty="0">
+              <a:rPr lang="en-US" sz="2700" dirty="0">
                 <a:solidFill>
                   <a:srgbClr val="FFFFFF"/>
                 </a:solidFill>
@@ -2572,7 +2572,7 @@
               </a:rPr>
               <a:t>Hole dein Heft heraus.</a:t>
             </a:r>
-            <a:endParaRPr lang="en-US" sz="2400" dirty="0"/>
+            <a:endParaRPr lang="en-US" sz="2700" dirty="0"/>
           </a:p>
         </p:txBody>
       </p:sp>
@@ -2660,7 +2660,7 @@
               <a:buNone/>
             </a:pPr>
             <a:r>
-              <a:rPr lang="en-US" sz="2400" dirty="0">
+              <a:rPr lang="en-US" sz="2700" dirty="0">
                 <a:solidFill>
                   <a:srgbClr val="FFFFFF"/>
                 </a:solidFill>
@@ -2670,7 +2670,7 @@
               </a:rPr>
               <a:t>Schreibe Datum und Überschrift „Der Dritte Stand handelt“.</a:t>
             </a:r>
-            <a:endParaRPr lang="en-US" sz="2400" dirty="0"/>
+            <a:endParaRPr lang="en-US" sz="2700" dirty="0"/>
           </a:p>
         </p:txBody>
       </p:sp>
@@ -2758,7 +2758,7 @@
               <a:buNone/>
             </a:pPr>
             <a:r>
-              <a:rPr lang="en-US" sz="2400" dirty="0">
+              <a:rPr lang="en-US" sz="2700" dirty="0">
                 <a:solidFill>
                   <a:srgbClr val="FFFFFF"/>
                 </a:solidFill>
@@ -2766,9 +2766,9 @@
                 <a:ea typeface="Calibri" pitchFamily="34" charset="-122"/>
                 <a:cs typeface="Calibri" pitchFamily="34" charset="-120"/>
               </a:rPr>
-              <a:t>Schreibe zwei Sätze: Was ist eine Revolution? Ist sie gut oder schlecht? Warum?</a:t>
-            </a:r>
-            <a:endParaRPr lang="en-US" sz="2400" dirty="0"/>
+              <a:t>Darf sich das Volk gegen einen König wehren, der allein regiert? Schreibe: Ich finde …, weil …</a:t>
+            </a:r>
+            <a:endParaRPr lang="en-US" sz="2700" dirty="0"/>
           </a:p>
         </p:txBody>
       </p:sp>
@@ -2973,7 +2973,7 @@
               <a:buNone/>
             </a:pPr>
             <a:r>
-              <a:rPr lang="en-US" sz="2400" dirty="0">
+              <a:rPr lang="en-US" sz="2700" dirty="0">
                 <a:solidFill>
                   <a:srgbClr val="1E2761"/>
                 </a:solidFill>
@@ -2987,7 +2987,7 @@
               <a:buNone/>
             </a:pPr>
             <a:r>
-              <a:rPr lang="en-US" sz="2400" b="1" dirty="0">
+              <a:rPr lang="en-US" sz="2700" b="1" dirty="0">
                 <a:solidFill>
                   <a:srgbClr val="1E2761"/>
                 </a:solidFill>
@@ -3001,7 +3001,7 @@
               <a:buNone/>
             </a:pPr>
             <a:r>
-              <a:rPr lang="en-US" sz="2400" dirty="0">
+              <a:rPr lang="en-US" sz="2700" dirty="0">
                 <a:solidFill>
                   <a:srgbClr val="1E2761"/>
                 </a:solidFill>
@@ -3015,7 +3015,7 @@
               <a:buNone/>
             </a:pPr>
             <a:r>
-              <a:rPr lang="en-US" sz="2400" b="1" dirty="0">
+              <a:rPr lang="en-US" sz="2700" b="1" dirty="0">
                 <a:solidFill>
                   <a:srgbClr val="1E2761"/>
                 </a:solidFill>
@@ -3029,7 +3029,7 @@
               <a:buNone/>
             </a:pPr>
             <a:r>
-              <a:rPr lang="en-US" sz="2400" dirty="0">
+              <a:rPr lang="en-US" sz="2700" dirty="0">
                 <a:solidFill>
                   <a:srgbClr val="1E2761"/>
                 </a:solidFill>
@@ -3043,7 +3043,7 @@
               <a:buNone/>
             </a:pPr>
             <a:r>
-              <a:rPr lang="en-US" sz="2400" b="1" dirty="0">
+              <a:rPr lang="en-US" sz="2700" b="1" dirty="0">
                 <a:solidFill>
                   <a:srgbClr val="1E2761"/>
                 </a:solidFill>
@@ -3057,7 +3057,7 @@
               <a:buNone/>
             </a:pPr>
             <a:r>
-              <a:rPr lang="en-US" sz="2400" dirty="0">
+              <a:rPr lang="en-US" sz="2700" dirty="0">
                 <a:solidFill>
                   <a:srgbClr val="1E2761"/>
                 </a:solidFill>
@@ -3071,7 +3071,7 @@
               <a:buNone/>
             </a:pPr>
             <a:r>
-              <a:rPr lang="en-US" sz="2400" b="1" dirty="0">
+              <a:rPr lang="en-US" sz="2700" b="1" dirty="0">
                 <a:solidFill>
                   <a:srgbClr val="1E2761"/>
                 </a:solidFill>
@@ -3085,7 +3085,7 @@
               <a:buNone/>
             </a:pPr>
             <a:r>
-              <a:rPr lang="en-US" sz="2400" dirty="0">
+              <a:rPr lang="en-US" sz="2700" dirty="0">
                 <a:solidFill>
                   <a:srgbClr val="1E2761"/>
                 </a:solidFill>
@@ -3099,7 +3099,7 @@
               <a:buNone/>
             </a:pPr>
             <a:r>
-              <a:rPr lang="en-US" sz="2400" b="1" dirty="0">
+              <a:rPr lang="en-US" sz="2700" b="1" dirty="0">
                 <a:solidFill>
                   <a:srgbClr val="1E2761"/>
                 </a:solidFill>
@@ -3113,7 +3113,7 @@
               <a:buNone/>
             </a:pPr>
             <a:r>
-              <a:rPr lang="en-US" sz="2400" dirty="0">
+              <a:rPr lang="en-US" sz="2700" dirty="0">
                 <a:solidFill>
                   <a:srgbClr val="1E2761"/>
                 </a:solidFill>
@@ -3123,7 +3123,7 @@
               </a:rPr>
               <a:t> infrage.</a:t>
             </a:r>
-            <a:endParaRPr lang="en-US" sz="2400" dirty="0"/>
+            <a:endParaRPr lang="en-US" sz="2700" dirty="0"/>
           </a:p>
         </p:txBody>
       </p:sp>
@@ -3174,7 +3174,7 @@
               <a:buNone/>
             </a:pPr>
             <a:r>
-              <a:rPr lang="en-US" sz="2400" b="1" dirty="0">
+              <a:rPr lang="en-US" sz="2700" b="1" dirty="0">
                 <a:solidFill>
                   <a:srgbClr val="5B6B8C"/>
                 </a:solidFill>
@@ -3188,7 +3188,7 @@
               <a:buNone/>
             </a:pPr>
             <a:r>
-              <a:rPr lang="en-US" sz="2400" dirty="0">
+              <a:rPr lang="en-US" sz="2700" dirty="0">
                 <a:solidFill>
                   <a:srgbClr val="1E2761"/>
                 </a:solidFill>
@@ -3202,7 +3202,7 @@
               <a:buNone/>
             </a:pPr>
             <a:r>
-              <a:rPr lang="en-US" sz="2400" b="1" dirty="0">
+              <a:rPr lang="en-US" sz="2700" b="1" dirty="0">
                 <a:solidFill>
                   <a:srgbClr val="1E2761"/>
                 </a:solidFill>
@@ -3216,7 +3216,7 @@
               <a:buNone/>
             </a:pPr>
             <a:r>
-              <a:rPr lang="en-US" sz="2400" dirty="0">
+              <a:rPr lang="en-US" sz="2700" dirty="0">
                 <a:solidFill>
                   <a:srgbClr val="1E2761"/>
                 </a:solidFill>
@@ -3230,7 +3230,7 @@
               <a:buNone/>
             </a:pPr>
             <a:r>
-              <a:rPr lang="en-US" sz="2400" b="1" dirty="0">
+              <a:rPr lang="en-US" sz="2700" b="1" dirty="0">
                 <a:solidFill>
                   <a:srgbClr val="1E2761"/>
                 </a:solidFill>
@@ -3244,7 +3244,7 @@
               <a:buNone/>
             </a:pPr>
             <a:r>
-              <a:rPr lang="en-US" sz="2400" dirty="0">
+              <a:rPr lang="en-US" sz="2700" dirty="0">
                 <a:solidFill>
                   <a:srgbClr val="1E2761"/>
                 </a:solidFill>
@@ -3258,7 +3258,7 @@
               <a:buNone/>
             </a:pPr>
             <a:r>
-              <a:rPr lang="en-US" sz="2400" b="1" dirty="0">
+              <a:rPr lang="en-US" sz="2700" b="1" dirty="0">
                 <a:solidFill>
                   <a:srgbClr val="1E2761"/>
                 </a:solidFill>
@@ -3272,7 +3272,7 @@
               <a:buNone/>
             </a:pPr>
             <a:r>
-              <a:rPr lang="en-US" sz="2400" dirty="0">
+              <a:rPr lang="en-US" sz="2700" dirty="0">
                 <a:solidFill>
                   <a:srgbClr val="1E2761"/>
                 </a:solidFill>
@@ -3282,7 +3282,7 @@
               </a:rPr>
               <a:t> sein.</a:t>
             </a:r>
-            <a:endParaRPr lang="en-US" sz="2400" dirty="0"/>
+            <a:endParaRPr lang="en-US" sz="2700" dirty="0"/>
           </a:p>
         </p:txBody>
       </p:sp>
@@ -3333,7 +3333,7 @@
               <a:buNone/>
             </a:pPr>
             <a:r>
-              <a:rPr lang="en-US" sz="2400" b="1" dirty="0">
+              <a:rPr lang="en-US" sz="2700" b="1" dirty="0">
                 <a:solidFill>
                   <a:srgbClr val="D9534F"/>
                 </a:solidFill>
@@ -3347,7 +3347,7 @@
               <a:buNone/>
             </a:pPr>
             <a:r>
-              <a:rPr lang="en-US" sz="2400" dirty="0">
+              <a:rPr lang="en-US" sz="2700" dirty="0">
                 <a:solidFill>
                   <a:srgbClr val="1E2761"/>
                 </a:solidFill>
@@ -3361,7 +3361,7 @@
               <a:buNone/>
             </a:pPr>
             <a:r>
-              <a:rPr lang="en-US" sz="2400" b="1" dirty="0">
+              <a:rPr lang="en-US" sz="2700" b="1" dirty="0">
                 <a:solidFill>
                   <a:srgbClr val="1E2761"/>
                 </a:solidFill>
@@ -3375,7 +3375,7 @@
               <a:buNone/>
             </a:pPr>
             <a:r>
-              <a:rPr lang="en-US" sz="2400" dirty="0">
+              <a:rPr lang="en-US" sz="2700" dirty="0">
                 <a:solidFill>
                   <a:srgbClr val="1E2761"/>
                 </a:solidFill>
@@ -3385,7 +3385,7 @@
               </a:rPr>
               <a:t> sie?</a:t>
             </a:r>
-            <a:endParaRPr lang="en-US" sz="2400" dirty="0"/>
+            <a:endParaRPr lang="en-US" sz="2700" dirty="0"/>
           </a:p>
         </p:txBody>
       </p:sp>
@@ -3436,7 +3436,7 @@
               <a:buNone/>
             </a:pPr>
             <a:r>
-              <a:rPr lang="en-US" sz="2400" b="1" dirty="0">
+              <a:rPr lang="en-US" sz="2700" b="1" dirty="0">
                 <a:solidFill>
                   <a:srgbClr val="FFFFFF"/>
                 </a:solidFill>
@@ -3450,7 +3450,7 @@
               <a:buNone/>
             </a:pPr>
             <a:r>
-              <a:rPr lang="en-US" sz="2400" dirty="0">
+              <a:rPr lang="en-US" sz="2700" dirty="0">
                 <a:solidFill>
                   <a:srgbClr val="FFFFFF"/>
                 </a:solidFill>
@@ -3464,7 +3464,7 @@
               <a:buNone/>
             </a:pPr>
             <a:r>
-              <a:rPr lang="en-US" sz="2400" i="1" dirty="0">
+              <a:rPr lang="en-US" sz="2700" i="1" dirty="0">
                 <a:solidFill>
                   <a:srgbClr val="CADCFC"/>
                 </a:solidFill>
@@ -3474,7 +3474,7 @@
               </a:rPr>
               <a:t>Fertig? Stift hinlegen.</a:t>
             </a:r>
-            <a:endParaRPr lang="en-US" sz="2400" dirty="0"/>
+            <a:endParaRPr lang="en-US" sz="2700" dirty="0"/>
           </a:p>
         </p:txBody>
       </p:sp>
@@ -4479,7 +4479,7 @@
               <a:buNone/>
             </a:pPr>
             <a:r>
-              <a:rPr lang="en-US" sz="2400" dirty="0">
+              <a:rPr lang="en-US" sz="2700" dirty="0">
                 <a:solidFill>
                   <a:srgbClr val="1E2761"/>
                 </a:solidFill>
@@ -4489,7 +4489,7 @@
               </a:rPr>
               <a:t>Was sehe ich? Personen, Dinge, Beischrift.</a:t>
             </a:r>
-            <a:endParaRPr lang="en-US" sz="2400" dirty="0"/>
+            <a:endParaRPr lang="en-US" sz="2700" dirty="0"/>
           </a:p>
         </p:txBody>
       </p:sp>
@@ -4638,7 +4638,7 @@
               <a:buNone/>
             </a:pPr>
             <a:r>
-              <a:rPr lang="en-US" sz="2400" dirty="0">
+              <a:rPr lang="en-US" sz="2700" dirty="0">
                 <a:solidFill>
                   <a:srgbClr val="1E2761"/>
                 </a:solidFill>
@@ -4648,7 +4648,7 @@
               </a:rPr>
               <a:t>Was soll es bedeuten? Wofür steht die Figur?</a:t>
             </a:r>
-            <a:endParaRPr lang="en-US" sz="2400" dirty="0"/>
+            <a:endParaRPr lang="en-US" sz="2700" dirty="0"/>
           </a:p>
         </p:txBody>
       </p:sp>
@@ -4797,7 +4797,7 @@
               <a:buNone/>
             </a:pPr>
             <a:r>
-              <a:rPr lang="en-US" sz="2400" dirty="0">
+              <a:rPr lang="en-US" sz="2700" dirty="0">
                 <a:solidFill>
                   <a:srgbClr val="1E2761"/>
                 </a:solidFill>
@@ -4805,9 +4805,9 @@
                 <a:ea typeface="Calibri" pitchFamily="34" charset="-122"/>
                 <a:cs typeface="Calibri" pitchFamily="34" charset="-120"/>
               </a:rPr>
-              <a:t>Ist das berechtigt? Was will der Zeichner erreichen?</a:t>
-            </a:r>
-            <a:endParaRPr lang="en-US" sz="2400" dirty="0"/>
+              <a:t>Stimmt das? Wo übertreibt es? Was will der Zeichner?</a:t>
+            </a:r>
+            <a:endParaRPr lang="en-US" sz="2700" dirty="0"/>
           </a:p>
         </p:txBody>
       </p:sp>
@@ -4858,7 +4858,7 @@
               <a:buNone/>
             </a:pPr>
             <a:r>
-              <a:rPr lang="en-US" sz="2400" b="1" dirty="0">
+              <a:rPr lang="en-US" sz="2700" b="1" dirty="0">
                 <a:solidFill>
                   <a:srgbClr val="FFFFFF"/>
                 </a:solidFill>
@@ -4872,7 +4872,7 @@
               <a:buNone/>
             </a:pPr>
             <a:r>
-              <a:rPr lang="en-US" sz="2400" dirty="0">
+              <a:rPr lang="en-US" sz="2700" dirty="0">
                 <a:solidFill>
                   <a:srgbClr val="FFFFFF"/>
                 </a:solidFill>
@@ -4882,7 +4882,7 @@
               </a:rPr>
               <a:t>Erst genau beschreiben, dann deuten, dann beurteilen.</a:t>
             </a:r>
-            <a:endParaRPr lang="en-US" sz="2400" dirty="0"/>
+            <a:endParaRPr lang="en-US" sz="2700" dirty="0"/>
           </a:p>
         </p:txBody>
       </p:sp>
@@ -5499,7 +5499,7 @@
               <a:buNone/>
             </a:pPr>
             <a:r>
-              <a:rPr lang="en-US" sz="2400" b="1" dirty="0">
+              <a:rPr lang="en-US" sz="2700" b="1" dirty="0">
                 <a:solidFill>
                   <a:srgbClr val="1E2761"/>
                 </a:solidFill>
@@ -5509,7 +5509,7 @@
               </a:rPr>
               <a:t>Beschreiben</a:t>
             </a:r>
-            <a:endParaRPr lang="en-US" sz="2400" dirty="0"/>
+            <a:endParaRPr lang="en-US" sz="2700" dirty="0"/>
           </a:p>
         </p:txBody>
       </p:sp>
@@ -5538,7 +5538,7 @@
               <a:buNone/>
             </a:pPr>
             <a:r>
-              <a:rPr lang="en-US" sz="2400" dirty="0">
+              <a:rPr lang="en-US" sz="2700" dirty="0">
                 <a:solidFill>
                   <a:srgbClr val="1E2761"/>
                 </a:solidFill>
@@ -5546,9 +5546,9 @@
                 <a:ea typeface="Calibri" pitchFamily="34" charset="-122"/>
                 <a:cs typeface="Calibri" pitchFamily="34" charset="-120"/>
               </a:rPr>
-              <a:t>Bauer, Geistlicher, Adliger, Hasen, Kohl, Beischrift</a:t>
-            </a:r>
-            <a:endParaRPr lang="en-US" sz="2400" dirty="0"/>
+              <a:t>Bauer, Geistlicher, Adliger, Hasen</a:t>
+            </a:r>
+            <a:endParaRPr lang="en-US" sz="2700" dirty="0"/>
           </a:p>
         </p:txBody>
       </p:sp>
@@ -5658,7 +5658,7 @@
               <a:buNone/>
             </a:pPr>
             <a:r>
-              <a:rPr lang="en-US" sz="2400" b="1" dirty="0">
+              <a:rPr lang="en-US" sz="2700" b="1" dirty="0">
                 <a:solidFill>
                   <a:srgbClr val="1E2761"/>
                 </a:solidFill>
@@ -5668,7 +5668,7 @@
               </a:rPr>
               <a:t>Deuten</a:t>
             </a:r>
-            <a:endParaRPr lang="en-US" sz="2400" dirty="0"/>
+            <a:endParaRPr lang="en-US" sz="2700" dirty="0"/>
           </a:p>
         </p:txBody>
       </p:sp>
@@ -5697,7 +5697,7 @@
               <a:buNone/>
             </a:pPr>
             <a:r>
-              <a:rPr lang="en-US" sz="2400" dirty="0">
+              <a:rPr lang="en-US" sz="2700" dirty="0">
                 <a:solidFill>
                   <a:srgbClr val="1E2761"/>
                 </a:solidFill>
@@ -5705,9 +5705,9 @@
                 <a:ea typeface="Calibri" pitchFamily="34" charset="-122"/>
                 <a:cs typeface="Calibri" pitchFamily="34" charset="-120"/>
               </a:rPr>
-              <a:t>Der Dritte Stand trägt die Last der beiden anderen</a:t>
-            </a:r>
-            <a:endParaRPr lang="en-US" sz="2400" dirty="0"/>
+              <a:t>Der Dritte Stand trägt die Last</a:t>
+            </a:r>
+            <a:endParaRPr lang="en-US" sz="2700" dirty="0"/>
           </a:p>
         </p:txBody>
       </p:sp>
@@ -5817,7 +5817,7 @@
               <a:buNone/>
             </a:pPr>
             <a:r>
-              <a:rPr lang="en-US" sz="2400" b="1" dirty="0">
+              <a:rPr lang="en-US" sz="2700" b="1" dirty="0">
                 <a:solidFill>
                   <a:srgbClr val="1E2761"/>
                 </a:solidFill>
@@ -5827,7 +5827,7 @@
               </a:rPr>
               <a:t>Beurteilen</a:t>
             </a:r>
-            <a:endParaRPr lang="en-US" sz="2400" dirty="0"/>
+            <a:endParaRPr lang="en-US" sz="2700" dirty="0"/>
           </a:p>
         </p:txBody>
       </p:sp>
@@ -5856,7 +5856,7 @@
               <a:buNone/>
             </a:pPr>
             <a:r>
-              <a:rPr lang="en-US" sz="2400" dirty="0">
+              <a:rPr lang="en-US" sz="2700" dirty="0">
                 <a:solidFill>
                   <a:srgbClr val="1E2761"/>
                 </a:solidFill>
@@ -5864,9 +5864,9 @@
                 <a:ea typeface="Calibri" pitchFamily="34" charset="-122"/>
                 <a:cs typeface="Calibri" pitchFamily="34" charset="-120"/>
               </a:rPr>
-              <a:t>Berechtigt? Er übertreibt, aber trifft den Kern</a:t>
-            </a:r>
-            <a:endParaRPr lang="en-US" sz="2400" dirty="0"/>
+              <a:t>Er übertreibt, trifft aber den Kern</a:t>
+            </a:r>
+            <a:endParaRPr lang="en-US" sz="2700" dirty="0"/>
           </a:p>
         </p:txBody>
       </p:sp>
@@ -5917,7 +5917,7 @@
               <a:buNone/>
             </a:pPr>
             <a:r>
-              <a:rPr lang="en-US" sz="2400" b="1" dirty="0">
+              <a:rPr lang="en-US" sz="2700" b="1" dirty="0">
                 <a:solidFill>
                   <a:srgbClr val="FFFFFF"/>
                 </a:solidFill>
@@ -5931,7 +5931,7 @@
               <a:buNone/>
             </a:pPr>
             <a:r>
-              <a:rPr lang="en-US" sz="2400" dirty="0">
+              <a:rPr lang="en-US" sz="2700" dirty="0">
                 <a:solidFill>
                   <a:srgbClr val="FFFFFF"/>
                 </a:solidFill>
@@ -5941,7 +5941,7 @@
               </a:rPr>
               <a:t>Stifte liegen. Ihr hört nur zu.</a:t>
             </a:r>
-            <a:endParaRPr lang="en-US" sz="2400" dirty="0"/>
+            <a:endParaRPr lang="en-US" sz="2700" dirty="0"/>
           </a:p>
         </p:txBody>
       </p:sp>
@@ -6460,12 +6460,12 @@
         </p:nvSpPr>
         <p:spPr>
           <a:xfrm>
-            <a:off x="3566160" y="1417320"/>
-            <a:ext cx="8092440" cy="1600200"/>
+            <a:off x="3566160" y="1371600"/>
+            <a:ext cx="8092440" cy="1188720"/>
           </a:xfrm>
           <a:prstGeom prst="roundRect">
             <a:avLst>
-              <a:gd name="adj" fmla="val 4571"/>
+              <a:gd name="adj" fmla="val 6154"/>
             </a:avLst>
           </a:prstGeom>
           <a:solidFill>
@@ -6482,8 +6482,8 @@
         </p:nvSpPr>
         <p:spPr>
           <a:xfrm>
-            <a:off x="3749040" y="1417320"/>
-            <a:ext cx="7726680" cy="1600200"/>
+            <a:off x="3749040" y="1371600"/>
+            <a:ext cx="7726680" cy="1188720"/>
           </a:xfrm>
           <a:prstGeom prst="rect">
             <a:avLst/>
@@ -6499,7 +6499,7 @@
               <a:buNone/>
             </a:pPr>
             <a:r>
-              <a:rPr lang="en-US" sz="2400" i="1" dirty="0">
+              <a:rPr lang="en-US" sz="2700" i="1" dirty="0">
                 <a:solidFill>
                   <a:srgbClr val="1E2761"/>
                 </a:solidFill>
@@ -6507,9 +6507,9 @@
                 <a:ea typeface="Cambria" pitchFamily="34" charset="-122"/>
                 <a:cs typeface="Cambria" pitchFamily="34" charset="-120"/>
               </a:rPr>
-              <a:t>„Jeden Tag mitten auf dem Feld … sieht man den armen Bauern … um mit seiner Arbeit das Geld zu verdienen und damit den Steuereintreiber zu bezahlen.“</a:t>
-            </a:r>
-            <a:endParaRPr lang="en-US" sz="2400" dirty="0"/>
+              <a:t>„… sieht man den armen Bauern … um mit seiner Arbeit das Geld zu verdienen und damit den Steuereintreiber zu bezahlen.“</a:t>
+            </a:r>
+            <a:endParaRPr lang="en-US" sz="2700" dirty="0"/>
           </a:p>
         </p:txBody>
       </p:sp>
@@ -6521,7 +6521,7 @@
         </p:nvSpPr>
         <p:spPr>
           <a:xfrm>
-            <a:off x="3657600" y="3246120"/>
+            <a:off x="3657600" y="2807208"/>
             <a:ext cx="411480" cy="411480"/>
           </a:xfrm>
           <a:prstGeom prst="ellipse">
@@ -6541,7 +6541,7 @@
         </p:nvSpPr>
         <p:spPr>
           <a:xfrm>
-            <a:off x="3657600" y="3246120"/>
+            <a:off x="3657600" y="2807208"/>
             <a:ext cx="411480" cy="411480"/>
           </a:xfrm>
           <a:prstGeom prst="rect">
@@ -6580,8 +6580,8 @@
         </p:nvSpPr>
         <p:spPr>
           <a:xfrm>
-            <a:off x="4297680" y="3200400"/>
-            <a:ext cx="7315200" cy="548640"/>
+            <a:off x="4297680" y="2743200"/>
+            <a:ext cx="7315200" cy="502920"/>
           </a:xfrm>
           <a:prstGeom prst="rect">
             <a:avLst/>
@@ -6597,7 +6597,7 @@
               <a:buNone/>
             </a:pPr>
             <a:r>
-              <a:rPr lang="en-US" sz="2400" b="1" dirty="0">
+              <a:rPr lang="en-US" sz="2700" b="1" dirty="0">
                 <a:solidFill>
                   <a:srgbClr val="1E2761"/>
                 </a:solidFill>
@@ -6607,7 +6607,7 @@
               </a:rPr>
               <a:t>Beschreibe die Karikatur in drei Sätzen.</a:t>
             </a:r>
-            <a:endParaRPr lang="en-US" sz="2400" dirty="0"/>
+            <a:endParaRPr lang="en-US" sz="2700" dirty="0"/>
           </a:p>
         </p:txBody>
       </p:sp>
@@ -6619,7 +6619,7 @@
         </p:nvSpPr>
         <p:spPr>
           <a:xfrm>
-            <a:off x="3657600" y="3867912"/>
+            <a:off x="3657600" y="3355848"/>
             <a:ext cx="411480" cy="411480"/>
           </a:xfrm>
           <a:prstGeom prst="ellipse">
@@ -6639,7 +6639,7 @@
         </p:nvSpPr>
         <p:spPr>
           <a:xfrm>
-            <a:off x="3657600" y="3867912"/>
+            <a:off x="3657600" y="3355848"/>
             <a:ext cx="411480" cy="411480"/>
           </a:xfrm>
           <a:prstGeom prst="rect">
@@ -6678,8 +6678,8 @@
         </p:nvSpPr>
         <p:spPr>
           <a:xfrm>
-            <a:off x="4297680" y="3822192"/>
-            <a:ext cx="7315200" cy="548640"/>
+            <a:off x="4297680" y="3291840"/>
+            <a:ext cx="7315200" cy="868680"/>
           </a:xfrm>
           <a:prstGeom prst="rect">
             <a:avLst/>
@@ -6695,7 +6695,7 @@
               <a:buNone/>
             </a:pPr>
             <a:r>
-              <a:rPr lang="en-US" sz="2400" b="1" dirty="0">
+              <a:rPr lang="en-US" sz="2700" b="1" dirty="0">
                 <a:solidFill>
                   <a:srgbClr val="1E2761"/>
                 </a:solidFill>
@@ -6705,7 +6705,7 @@
               </a:rPr>
               <a:t>Deute: Wofür steht der Bauer? Was sagt der Bildtext?</a:t>
             </a:r>
-            <a:endParaRPr lang="en-US" sz="2400" dirty="0"/>
+            <a:endParaRPr lang="en-US" sz="2700" dirty="0"/>
           </a:p>
         </p:txBody>
       </p:sp>
@@ -6717,7 +6717,7 @@
         </p:nvSpPr>
         <p:spPr>
           <a:xfrm>
-            <a:off x="3657600" y="4489704"/>
+            <a:off x="3657600" y="4270248"/>
             <a:ext cx="411480" cy="411480"/>
           </a:xfrm>
           <a:prstGeom prst="ellipse">
@@ -6737,7 +6737,7 @@
         </p:nvSpPr>
         <p:spPr>
           <a:xfrm>
-            <a:off x="3657600" y="4489704"/>
+            <a:off x="3657600" y="4270248"/>
             <a:ext cx="411480" cy="411480"/>
           </a:xfrm>
           <a:prstGeom prst="rect">
@@ -6776,8 +6776,8 @@
         </p:nvSpPr>
         <p:spPr>
           <a:xfrm>
-            <a:off x="4297680" y="4443984"/>
-            <a:ext cx="7315200" cy="548640"/>
+            <a:off x="4297680" y="4206240"/>
+            <a:ext cx="7315200" cy="1097280"/>
           </a:xfrm>
           <a:prstGeom prst="rect">
             <a:avLst/>
@@ -6793,7 +6793,7 @@
               <a:buNone/>
             </a:pPr>
             <a:r>
-              <a:rPr lang="en-US" sz="2400" b="1" dirty="0">
+              <a:rPr lang="en-US" sz="2700" b="1" dirty="0">
                 <a:solidFill>
                   <a:srgbClr val="1E2761"/>
                 </a:solidFill>
@@ -6801,9 +6801,9 @@
                 <a:ea typeface="Calibri" pitchFamily="34" charset="-122"/>
                 <a:cs typeface="Calibri" pitchFamily="34" charset="-120"/>
               </a:rPr>
-              <a:t>Beurteile: Ist die Darstellung berechtigt? *</a:t>
-            </a:r>
-            <a:endParaRPr lang="en-US" sz="2400" dirty="0"/>
+              <a:t>Beurteile: Stimmt das Bild mit unserem Wissen über Steuern? Wo übertreibt es? *</a:t>
+            </a:r>
+            <a:endParaRPr lang="en-US" sz="2700" dirty="0"/>
           </a:p>
         </p:txBody>
       </p:sp>
@@ -6815,8 +6815,8 @@
         </p:nvSpPr>
         <p:spPr>
           <a:xfrm>
-            <a:off x="3566160" y="5166360"/>
-            <a:ext cx="8046720" cy="365760"/>
+            <a:off x="3566160" y="5257800"/>
+            <a:ext cx="8092440" cy="411480"/>
           </a:xfrm>
           <a:prstGeom prst="rect">
             <a:avLst/>
@@ -6832,7 +6832,7 @@
               <a:buNone/>
             </a:pPr>
             <a:r>
-              <a:rPr lang="en-US" sz="2400" dirty="0">
+              <a:rPr lang="en-US" sz="2700" dirty="0">
                 <a:solidFill>
                   <a:srgbClr val="5B6B8C"/>
                 </a:solidFill>
@@ -6842,7 +6842,7 @@
               </a:rPr>
               <a:t>Hilfe: Schnipsel auf dem Tisch · Hilfekarten am Pult</a:t>
             </a:r>
-            <a:endParaRPr lang="en-US" sz="2400" dirty="0"/>
+            <a:endParaRPr lang="en-US" sz="2700" dirty="0"/>
           </a:p>
         </p:txBody>
       </p:sp>
@@ -6893,7 +6893,7 @@
               <a:buNone/>
             </a:pPr>
             <a:r>
-              <a:rPr lang="en-US" sz="2400" b="1" dirty="0">
+              <a:rPr lang="en-US" sz="2700" b="1" dirty="0">
                 <a:solidFill>
                   <a:srgbClr val="FFFFFF"/>
                 </a:solidFill>
@@ -6907,7 +6907,7 @@
               <a:buNone/>
             </a:pPr>
             <a:r>
-              <a:rPr lang="en-US" sz="2400" dirty="0">
+              <a:rPr lang="en-US" sz="2700" dirty="0">
                 <a:solidFill>
                   <a:srgbClr val="FFFFFF"/>
                 </a:solidFill>
@@ -6921,7 +6921,7 @@
               <a:buNone/>
             </a:pPr>
             <a:r>
-              <a:rPr lang="en-US" sz="2400" i="1" dirty="0">
+              <a:rPr lang="en-US" sz="2700" i="1" dirty="0">
                 <a:solidFill>
                   <a:srgbClr val="CADCFC"/>
                 </a:solidFill>
@@ -6931,7 +6931,7 @@
               </a:rPr>
               <a:t>Fertig? Stift hinlegen.</a:t>
             </a:r>
-            <a:endParaRPr lang="en-US" sz="2400" dirty="0"/>
+            <a:endParaRPr lang="en-US" sz="2700" dirty="0"/>
           </a:p>
         </p:txBody>
       </p:sp>
@@ -7465,7 +7465,7 @@
               <a:buNone/>
             </a:pPr>
             <a:r>
-              <a:rPr lang="en-US" sz="2400" b="1" dirty="0">
+              <a:rPr lang="en-US" sz="2700" b="1" dirty="0">
                 <a:solidFill>
                   <a:srgbClr val="1E2761"/>
                 </a:solidFill>
@@ -7475,7 +7475,7 @@
               </a:rPr>
               <a:t>1 Beschreiben</a:t>
             </a:r>
-            <a:endParaRPr lang="en-US" sz="2400" dirty="0"/>
+            <a:endParaRPr lang="en-US" sz="2700" dirty="0"/>
           </a:p>
         </p:txBody>
       </p:sp>
@@ -7504,7 +7504,7 @@
               <a:buNone/>
             </a:pPr>
             <a:r>
-              <a:rPr lang="en-US" sz="2400" dirty="0">
+              <a:rPr lang="en-US" sz="2700" dirty="0">
                 <a:solidFill>
                   <a:srgbClr val="1E2761"/>
                 </a:solidFill>
@@ -7514,7 +7514,7 @@
               </a:rPr>
               <a:t>Ein großer Bauer mit Hut, Stock und Sack. Hinten ein Dorf, Tiere und ein Arbeiter.</a:t>
             </a:r>
-            <a:endParaRPr lang="en-US" sz="2400" dirty="0"/>
+            <a:endParaRPr lang="en-US" sz="2700" dirty="0"/>
           </a:p>
         </p:txBody>
       </p:sp>
@@ -7565,7 +7565,7 @@
               <a:buNone/>
             </a:pPr>
             <a:r>
-              <a:rPr lang="en-US" sz="2400" b="1" dirty="0">
+              <a:rPr lang="en-US" sz="2700" b="1" dirty="0">
                 <a:solidFill>
                   <a:srgbClr val="1E2761"/>
                 </a:solidFill>
@@ -7575,7 +7575,7 @@
               </a:rPr>
               <a:t>2 Deuten</a:t>
             </a:r>
-            <a:endParaRPr lang="en-US" sz="2400" dirty="0"/>
+            <a:endParaRPr lang="en-US" sz="2700" dirty="0"/>
           </a:p>
         </p:txBody>
       </p:sp>
@@ -7604,7 +7604,7 @@
               <a:buNone/>
             </a:pPr>
             <a:r>
-              <a:rPr lang="en-US" sz="2400" dirty="0">
+              <a:rPr lang="en-US" sz="2700" dirty="0">
                 <a:solidFill>
                   <a:srgbClr val="1E2761"/>
                 </a:solidFill>
@@ -7614,7 +7614,7 @@
               </a:rPr>
               <a:t>Der Bauer steht für den Dritten Stand (Bauern und Bürger). Er arbeitet das ganze Jahr, um Steuern zu zahlen.</a:t>
             </a:r>
-            <a:endParaRPr lang="en-US" sz="2400" dirty="0"/>
+            <a:endParaRPr lang="en-US" sz="2700" dirty="0"/>
           </a:p>
         </p:txBody>
       </p:sp>
@@ -7665,7 +7665,7 @@
               <a:buNone/>
             </a:pPr>
             <a:r>
-              <a:rPr lang="en-US" sz="2400" b="1" dirty="0">
+              <a:rPr lang="en-US" sz="2700" b="1" dirty="0">
                 <a:solidFill>
                   <a:srgbClr val="1E2761"/>
                 </a:solidFill>
@@ -7675,7 +7675,7 @@
               </a:rPr>
               <a:t>3 Beurteilen*</a:t>
             </a:r>
-            <a:endParaRPr lang="en-US" sz="2400" dirty="0"/>
+            <a:endParaRPr lang="en-US" sz="2700" dirty="0"/>
           </a:p>
         </p:txBody>
       </p:sp>
@@ -7704,7 +7704,7 @@
               <a:buNone/>
             </a:pPr>
             <a:r>
-              <a:rPr lang="en-US" sz="2400" dirty="0">
+              <a:rPr lang="en-US" sz="2700" dirty="0">
                 <a:solidFill>
                   <a:srgbClr val="1E2761"/>
                 </a:solidFill>
@@ -7714,7 +7714,7 @@
               </a:rPr>
               <a:t>Der Zeichner will Mitleid und Veränderung. Das stimmt mit den Beschwerden überein, ist aber auch übertrieben.</a:t>
             </a:r>
-            <a:endParaRPr lang="en-US" sz="2400" dirty="0"/>
+            <a:endParaRPr lang="en-US" sz="2700" dirty="0"/>
           </a:p>
         </p:txBody>
       </p:sp>
@@ -7765,7 +7765,7 @@
               <a:buNone/>
             </a:pPr>
             <a:r>
-              <a:rPr lang="en-US" sz="2400" b="1" dirty="0">
+              <a:rPr lang="en-US" sz="2700" b="1" dirty="0">
                 <a:solidFill>
                   <a:srgbClr val="FFFFFF"/>
                 </a:solidFill>
@@ -7779,7 +7779,7 @@
               <a:buNone/>
             </a:pPr>
             <a:r>
-              <a:rPr lang="en-US" sz="2400" dirty="0">
+              <a:rPr lang="en-US" sz="2700" dirty="0">
                 <a:solidFill>
                   <a:srgbClr val="FFFFFF"/>
                 </a:solidFill>
@@ -7789,7 +7789,7 @@
               </a:rPr>
               <a:t>Vergleiche mit deiner Analyse und verbessere mit Grün.</a:t>
             </a:r>
-            <a:endParaRPr lang="en-US" sz="2400" dirty="0"/>
+            <a:endParaRPr lang="en-US" sz="2700" dirty="0"/>
           </a:p>
         </p:txBody>
       </p:sp>
@@ -8325,7 +8325,7 @@
               <a:buNone/>
             </a:pPr>
             <a:r>
-              <a:rPr lang="en-US" sz="2400" b="1" dirty="0">
+              <a:rPr lang="en-US" sz="2700" b="1" dirty="0">
                 <a:solidFill>
                   <a:srgbClr val="1E2761"/>
                 </a:solidFill>
@@ -8335,7 +8335,7 @@
               </a:rPr>
               <a:t>Abgeordneter</a:t>
             </a:r>
-            <a:endParaRPr lang="en-US" sz="2400" dirty="0"/>
+            <a:endParaRPr lang="en-US" sz="2700" dirty="0"/>
           </a:p>
         </p:txBody>
       </p:sp>
@@ -8444,7 +8444,7 @@
                 <a:ea typeface="Cambria" pitchFamily="34" charset="-122"/>
                 <a:cs typeface="Cambria" pitchFamily="34" charset="-120"/>
               </a:rPr>
-              <a:t>„Der König hat den Saal sperren lassen. Sollen wir nach Hause gehen oder schwören, zusammenzubleiben?“</a:t>
+              <a:t>„Draußen stehen Soldaten. Wenn ich schwöre, kann ich verhaftet werden, auch meine Familie ist in Gefahr. Soll ich trotzdem schwören?“</a:t>
             </a:r>
             <a:endParaRPr lang="en-US" sz="2600" dirty="0"/>
           </a:p>
@@ -8555,7 +8555,7 @@
                 <a:ea typeface="Cambria" pitchFamily="34" charset="-122"/>
                 <a:cs typeface="Cambria" pitchFamily="34" charset="-120"/>
               </a:rPr>
-              <a:t>Dein Rat:  „Ich rate euch, … , weil …“</a:t>
+              <a:t>Dein Rat:  „Ich rate dir, … , weil …“</a:t>
             </a:r>
             <a:endParaRPr lang="en-US" sz="2600" dirty="0"/>
           </a:p>
@@ -8610,7 +8610,7 @@
               <a:buNone/>
             </a:pPr>
             <a:r>
-              <a:rPr lang="en-US" sz="2400" b="1" dirty="0">
+              <a:rPr lang="en-US" sz="2700" b="1" dirty="0">
                 <a:solidFill>
                   <a:srgbClr val="1E2761"/>
                 </a:solidFill>
@@ -8620,7 +8620,7 @@
               </a:rPr>
               <a:t>Du</a:t>
             </a:r>
-            <a:endParaRPr lang="en-US" sz="2400" dirty="0"/>
+            <a:endParaRPr lang="en-US" sz="2700" dirty="0"/>
           </a:p>
         </p:txBody>
       </p:sp>
@@ -8671,7 +8671,7 @@
               <a:buNone/>
             </a:pPr>
             <a:r>
-              <a:rPr lang="en-US" sz="2400" b="1" dirty="0">
+              <a:rPr lang="en-US" sz="2700" b="1" dirty="0">
                 <a:solidFill>
                   <a:srgbClr val="1E2761"/>
                 </a:solidFill>
@@ -8681,7 +8681,7 @@
               </a:rPr>
               <a:t>Position</a:t>
             </a:r>
-            <a:endParaRPr lang="en-US" sz="2400" dirty="0"/>
+            <a:endParaRPr lang="en-US" sz="2700" dirty="0"/>
           </a:p>
         </p:txBody>
       </p:sp>
@@ -8732,7 +8732,7 @@
               <a:buNone/>
             </a:pPr>
             <a:r>
-              <a:rPr lang="en-US" sz="2400" b="1" dirty="0">
+              <a:rPr lang="en-US" sz="2700" b="1" dirty="0">
                 <a:solidFill>
                   <a:srgbClr val="1E2761"/>
                 </a:solidFill>
@@ -8742,7 +8742,7 @@
               </a:rPr>
               <a:t>Sachargument</a:t>
             </a:r>
-            <a:endParaRPr lang="en-US" sz="2400" dirty="0"/>
+            <a:endParaRPr lang="en-US" sz="2700" dirty="0"/>
           </a:p>
         </p:txBody>
       </p:sp>
@@ -8793,7 +8793,7 @@
               <a:buNone/>
             </a:pPr>
             <a:r>
-              <a:rPr lang="en-US" sz="2400" b="1" dirty="0">
+              <a:rPr lang="en-US" sz="2700" b="1" dirty="0">
                 <a:solidFill>
                   <a:srgbClr val="1E2761"/>
                 </a:solidFill>
@@ -8803,7 +8803,7 @@
               </a:rPr>
               <a:t>„weil“</a:t>
             </a:r>
-            <a:endParaRPr lang="en-US" sz="2400" dirty="0"/>
+            <a:endParaRPr lang="en-US" sz="2700" dirty="0"/>
           </a:p>
         </p:txBody>
       </p:sp>
@@ -8854,7 +8854,7 @@
               <a:buNone/>
             </a:pPr>
             <a:r>
-              <a:rPr lang="en-US" sz="2400" b="1" dirty="0">
+              <a:rPr lang="en-US" sz="2700" b="1" dirty="0">
                 <a:solidFill>
                   <a:srgbClr val="FFFFFF"/>
                 </a:solidFill>
@@ -8868,7 +8868,7 @@
               <a:buNone/>
             </a:pPr>
             <a:r>
-              <a:rPr lang="en-US" sz="2400" dirty="0">
+              <a:rPr lang="en-US" sz="2700" dirty="0">
                 <a:solidFill>
                   <a:srgbClr val="FFFFFF"/>
                 </a:solidFill>
@@ -8882,7 +8882,7 @@
               <a:buNone/>
             </a:pPr>
             <a:r>
-              <a:rPr lang="en-US" sz="2400" i="1" dirty="0">
+              <a:rPr lang="en-US" sz="2700" i="1" dirty="0">
                 <a:solidFill>
                   <a:srgbClr val="CADCFC"/>
                 </a:solidFill>
@@ -8892,7 +8892,7 @@
               </a:rPr>
               <a:t>Fertig? Stift hinlegen.</a:t>
             </a:r>
-            <a:endParaRPr lang="en-US" sz="2400" dirty="0"/>
+            <a:endParaRPr lang="en-US" sz="2700" dirty="0"/>
           </a:p>
         </p:txBody>
       </p:sp>
@@ -9451,7 +9451,7 @@
               <a:buNone/>
             </a:pPr>
             <a:r>
-              <a:rPr lang="en-US" sz="2400" dirty="0">
+              <a:rPr lang="en-US" sz="2700" dirty="0">
                 <a:solidFill>
                   <a:srgbClr val="1E2761"/>
                 </a:solidFill>
@@ -9461,7 +9461,7 @@
               </a:rPr>
               <a:t>Ich kann erklären, warum sich der Dritte Stand (Bauern und Bürger) 1789 zur Nationalversammlung erklärte.</a:t>
             </a:r>
-            <a:endParaRPr lang="en-US" sz="2400" dirty="0"/>
+            <a:endParaRPr lang="en-US" sz="2700" dirty="0"/>
           </a:p>
         </p:txBody>
       </p:sp>
@@ -9537,7 +9537,7 @@
               <a:buNone/>
             </a:pPr>
             <a:r>
-              <a:rPr lang="en-US" sz="2400" dirty="0">
+              <a:rPr lang="en-US" sz="2700" dirty="0">
                 <a:solidFill>
                   <a:srgbClr val="1E2761"/>
                 </a:solidFill>
@@ -9547,7 +9547,7 @@
               </a:rPr>
               <a:t>Ich kann erklären, was die Abgeordneten im Ballhausschwur versprachen.</a:t>
             </a:r>
-            <a:endParaRPr lang="en-US" sz="2400" dirty="0"/>
+            <a:endParaRPr lang="en-US" sz="2700" dirty="0"/>
           </a:p>
         </p:txBody>
       </p:sp>
@@ -9623,7 +9623,7 @@
               <a:buNone/>
             </a:pPr>
             <a:r>
-              <a:rPr lang="en-US" sz="2400" dirty="0">
+              <a:rPr lang="en-US" sz="2700" dirty="0">
                 <a:solidFill>
                   <a:srgbClr val="1E2761"/>
                 </a:solidFill>
@@ -9633,7 +9633,7 @@
               </a:rPr>
               <a:t>Ich kann eine Karikatur analysieren: beschreiben, deuten, beurteilen.*</a:t>
             </a:r>
-            <a:endParaRPr lang="en-US" sz="2400" dirty="0"/>
+            <a:endParaRPr lang="en-US" sz="2700" dirty="0"/>
           </a:p>
         </p:txBody>
       </p:sp>
@@ -9684,7 +9684,7 @@
               <a:buNone/>
             </a:pPr>
             <a:r>
-              <a:rPr lang="en-US" sz="2400" b="1" dirty="0">
+              <a:rPr lang="en-US" sz="2700" b="1" dirty="0">
                 <a:solidFill>
                   <a:srgbClr val="FFFFFF"/>
                 </a:solidFill>
@@ -9698,7 +9698,7 @@
               <a:buNone/>
             </a:pPr>
             <a:r>
-              <a:rPr lang="en-US" sz="2400" dirty="0">
+              <a:rPr lang="en-US" sz="2700" dirty="0">
                 <a:solidFill>
                   <a:srgbClr val="FFFFFF"/>
                 </a:solidFill>
@@ -9708,7 +9708,7 @@
               </a:rPr>
               <a:t>Schau auf die Ziele. Haben wir sie erreicht?</a:t>
             </a:r>
-            <a:endParaRPr lang="en-US" sz="2400" dirty="0"/>
+            <a:endParaRPr lang="en-US" sz="2700" dirty="0"/>
           </a:p>
         </p:txBody>
       </p:sp>
@@ -10381,7 +10381,7 @@
               <a:buNone/>
             </a:pPr>
             <a:r>
-              <a:rPr lang="en-US" sz="2400" b="1" dirty="0">
+              <a:rPr lang="en-US" sz="2700" b="1" dirty="0">
                 <a:solidFill>
                   <a:srgbClr val="FFFFFF"/>
                 </a:solidFill>
@@ -10395,7 +10395,7 @@
               <a:buNone/>
             </a:pPr>
             <a:r>
-              <a:rPr lang="en-US" sz="2400" dirty="0">
+              <a:rPr lang="en-US" sz="2700" dirty="0">
                 <a:solidFill>
                   <a:srgbClr val="FFFFFF"/>
                 </a:solidFill>
@@ -10405,7 +10405,7 @@
               </a:rPr>
               <a:t>Bastille, Ende der Vorrechte, Menschenrechte.</a:t>
             </a:r>
-            <a:endParaRPr lang="en-US" sz="2400" dirty="0"/>
+            <a:endParaRPr lang="en-US" sz="2700" dirty="0"/>
           </a:p>
         </p:txBody>
       </p:sp>
@@ -10703,7 +10703,7 @@
               <a:buNone/>
             </a:pPr>
             <a:r>
-              <a:rPr lang="en-US" sz="2400" dirty="0">
+              <a:rPr lang="en-US" sz="2700" dirty="0">
                 <a:solidFill>
                   <a:srgbClr val="1E2761"/>
                 </a:solidFill>
@@ -10713,7 +10713,7 @@
               </a:rPr>
               <a:t>Ich kann erklären, warum sich der Dritte Stand (Bauern und Bürger) 1789 zur Nationalversammlung erklärte.</a:t>
             </a:r>
-            <a:endParaRPr lang="en-US" sz="2400" dirty="0"/>
+            <a:endParaRPr lang="en-US" sz="2700" dirty="0"/>
           </a:p>
         </p:txBody>
       </p:sp>
@@ -10823,7 +10823,7 @@
               <a:buNone/>
             </a:pPr>
             <a:r>
-              <a:rPr lang="en-US" sz="2400" dirty="0">
+              <a:rPr lang="en-US" sz="2700" dirty="0">
                 <a:solidFill>
                   <a:srgbClr val="1E2761"/>
                 </a:solidFill>
@@ -10833,7 +10833,7 @@
               </a:rPr>
               <a:t>Ich kann erklären, was die Abgeordneten im Ballhausschwur versprachen.</a:t>
             </a:r>
-            <a:endParaRPr lang="en-US" sz="2400" dirty="0"/>
+            <a:endParaRPr lang="en-US" sz="2700" dirty="0"/>
           </a:p>
         </p:txBody>
       </p:sp>
@@ -10943,7 +10943,7 @@
               <a:buNone/>
             </a:pPr>
             <a:r>
-              <a:rPr lang="en-US" sz="2400" dirty="0">
+              <a:rPr lang="en-US" sz="2700" dirty="0">
                 <a:solidFill>
                   <a:srgbClr val="1E2761"/>
                 </a:solidFill>
@@ -10953,7 +10953,7 @@
               </a:rPr>
               <a:t>Ich kann eine Karikatur analysieren: beschreiben, deuten, beurteilen.*</a:t>
             </a:r>
-            <a:endParaRPr lang="en-US" sz="2400" dirty="0"/>
+            <a:endParaRPr lang="en-US" sz="2700" dirty="0"/>
           </a:p>
         </p:txBody>
       </p:sp>
@@ -11004,7 +11004,7 @@
               <a:buNone/>
             </a:pPr>
             <a:r>
-              <a:rPr lang="en-US" sz="2400" b="1" dirty="0">
+              <a:rPr lang="en-US" sz="2700" b="1" dirty="0">
                 <a:solidFill>
                   <a:srgbClr val="FFFFFF"/>
                 </a:solidFill>
@@ -11018,7 +11018,7 @@
               <a:buNone/>
             </a:pPr>
             <a:r>
-              <a:rPr lang="en-US" sz="2400" dirty="0">
+              <a:rPr lang="en-US" sz="2700" dirty="0">
                 <a:solidFill>
                   <a:srgbClr val="FFFFFF"/>
                 </a:solidFill>
@@ -11028,7 +11028,7 @@
               </a:rPr>
               <a:t>Nationalversammlung, Ballhausschwur und eine Karikatur.</a:t>
             </a:r>
-            <a:endParaRPr lang="en-US" sz="2400" dirty="0"/>
+            <a:endParaRPr lang="en-US" sz="2700" dirty="0"/>
           </a:p>
         </p:txBody>
       </p:sp>
@@ -11326,7 +11326,7 @@
               <a:buNone/>
             </a:pPr>
             <a:r>
-              <a:rPr lang="en-US" sz="2400" b="1" dirty="0">
+              <a:rPr lang="en-US" sz="2700" b="1" dirty="0">
                 <a:solidFill>
                   <a:srgbClr val="1E2761"/>
                 </a:solidFill>
@@ -11336,7 +11336,7 @@
               </a:rPr>
               <a:t>Ankommen</a:t>
             </a:r>
-            <a:endParaRPr lang="en-US" sz="2400" dirty="0"/>
+            <a:endParaRPr lang="en-US" sz="2700" dirty="0"/>
           </a:p>
         </p:txBody>
       </p:sp>
@@ -11365,7 +11365,7 @@
               <a:buNone/>
             </a:pPr>
             <a:r>
-              <a:rPr lang="en-US" sz="2400" dirty="0">
+              <a:rPr lang="en-US" sz="2700" dirty="0">
                 <a:solidFill>
                   <a:srgbClr val="5B6B8C"/>
                 </a:solidFill>
@@ -11375,7 +11375,7 @@
               </a:rPr>
               <a:t>Ziele</a:t>
             </a:r>
-            <a:endParaRPr lang="en-US" sz="2400" dirty="0"/>
+            <a:endParaRPr lang="en-US" sz="2700" dirty="0"/>
           </a:p>
         </p:txBody>
       </p:sp>
@@ -11404,7 +11404,7 @@
               <a:buNone/>
             </a:pPr>
             <a:r>
-              <a:rPr lang="en-US" sz="2400" b="1" dirty="0">
+              <a:rPr lang="en-US" sz="2700" b="1" dirty="0">
                 <a:solidFill>
                   <a:srgbClr val="D9534F"/>
                 </a:solidFill>
@@ -11414,7 +11414,7 @@
               </a:rPr>
               <a:t>3 Min.</a:t>
             </a:r>
-            <a:endParaRPr lang="en-US" sz="2400" dirty="0"/>
+            <a:endParaRPr lang="en-US" sz="2700" dirty="0"/>
           </a:p>
         </p:txBody>
       </p:sp>
@@ -11524,7 +11524,7 @@
               <a:buNone/>
             </a:pPr>
             <a:r>
-              <a:rPr lang="en-US" sz="2400" b="1" dirty="0">
+              <a:rPr lang="en-US" sz="2700" b="1" dirty="0">
                 <a:solidFill>
                   <a:srgbClr val="1E2761"/>
                 </a:solidFill>
@@ -11534,7 +11534,7 @@
               </a:rPr>
               <a:t>Vorwissen</a:t>
             </a:r>
-            <a:endParaRPr lang="en-US" sz="2400" dirty="0"/>
+            <a:endParaRPr lang="en-US" sz="2700" dirty="0"/>
           </a:p>
         </p:txBody>
       </p:sp>
@@ -11563,7 +11563,7 @@
               <a:buNone/>
             </a:pPr>
             <a:r>
-              <a:rPr lang="en-US" sz="2400" dirty="0">
+              <a:rPr lang="en-US" sz="2700" dirty="0">
                 <a:solidFill>
                   <a:srgbClr val="5B6B8C"/>
                 </a:solidFill>
@@ -11573,7 +11573,7 @@
               </a:rPr>
               <a:t>Abstimmung</a:t>
             </a:r>
-            <a:endParaRPr lang="en-US" sz="2400" dirty="0"/>
+            <a:endParaRPr lang="en-US" sz="2700" dirty="0"/>
           </a:p>
         </p:txBody>
       </p:sp>
@@ -11602,7 +11602,7 @@
               <a:buNone/>
             </a:pPr>
             <a:r>
-              <a:rPr lang="en-US" sz="2400" b="1" dirty="0">
+              <a:rPr lang="en-US" sz="2700" b="1" dirty="0">
                 <a:solidFill>
                   <a:srgbClr val="D9534F"/>
                 </a:solidFill>
@@ -11612,7 +11612,7 @@
               </a:rPr>
               <a:t>6 Min.</a:t>
             </a:r>
-            <a:endParaRPr lang="en-US" sz="2400" dirty="0"/>
+            <a:endParaRPr lang="en-US" sz="2700" dirty="0"/>
           </a:p>
         </p:txBody>
       </p:sp>
@@ -11722,7 +11722,7 @@
               <a:buNone/>
             </a:pPr>
             <a:r>
-              <a:rPr lang="en-US" sz="2400" b="1" dirty="0">
+              <a:rPr lang="en-US" sz="2700" b="1" dirty="0">
                 <a:solidFill>
                   <a:srgbClr val="1E2761"/>
                 </a:solidFill>
@@ -11732,7 +11732,7 @@
               </a:rPr>
               <a:t>Informieren</a:t>
             </a:r>
-            <a:endParaRPr lang="en-US" sz="2400" dirty="0"/>
+            <a:endParaRPr lang="en-US" sz="2700" dirty="0"/>
           </a:p>
         </p:txBody>
       </p:sp>
@@ -11761,7 +11761,7 @@
               <a:buNone/>
             </a:pPr>
             <a:r>
-              <a:rPr lang="en-US" sz="2400" dirty="0">
+              <a:rPr lang="en-US" sz="2700" dirty="0">
                 <a:solidFill>
                   <a:srgbClr val="5B6B8C"/>
                 </a:solidFill>
@@ -11771,7 +11771,7 @@
               </a:rPr>
               <a:t>Text, Zeitstrahl</a:t>
             </a:r>
-            <a:endParaRPr lang="en-US" sz="2400" dirty="0"/>
+            <a:endParaRPr lang="en-US" sz="2700" dirty="0"/>
           </a:p>
         </p:txBody>
       </p:sp>
@@ -11800,7 +11800,7 @@
               <a:buNone/>
             </a:pPr>
             <a:r>
-              <a:rPr lang="en-US" sz="2400" b="1" dirty="0">
+              <a:rPr lang="en-US" sz="2700" b="1" dirty="0">
                 <a:solidFill>
                   <a:srgbClr val="D9534F"/>
                 </a:solidFill>
@@ -11810,7 +11810,7 @@
               </a:rPr>
               <a:t>12 Min.</a:t>
             </a:r>
-            <a:endParaRPr lang="en-US" sz="2400" dirty="0"/>
+            <a:endParaRPr lang="en-US" sz="2700" dirty="0"/>
           </a:p>
         </p:txBody>
       </p:sp>
@@ -11920,7 +11920,7 @@
               <a:buNone/>
             </a:pPr>
             <a:r>
-              <a:rPr lang="en-US" sz="2400" b="1" dirty="0">
+              <a:rPr lang="en-US" sz="2700" b="1" dirty="0">
                 <a:solidFill>
                   <a:srgbClr val="1E2761"/>
                 </a:solidFill>
@@ -11930,7 +11930,7 @@
               </a:rPr>
               <a:t>Verarbeiten</a:t>
             </a:r>
-            <a:endParaRPr lang="en-US" sz="2400" dirty="0"/>
+            <a:endParaRPr lang="en-US" sz="2700" dirty="0"/>
           </a:p>
         </p:txBody>
       </p:sp>
@@ -11959,7 +11959,7 @@
               <a:buNone/>
             </a:pPr>
             <a:r>
-              <a:rPr lang="en-US" sz="2400" dirty="0">
+              <a:rPr lang="en-US" sz="2700" dirty="0">
                 <a:solidFill>
                   <a:srgbClr val="5B6B8C"/>
                 </a:solidFill>
@@ -11969,7 +11969,7 @@
               </a:rPr>
               <a:t>Karikatur</a:t>
             </a:r>
-            <a:endParaRPr lang="en-US" sz="2400" dirty="0"/>
+            <a:endParaRPr lang="en-US" sz="2700" dirty="0"/>
           </a:p>
         </p:txBody>
       </p:sp>
@@ -11998,7 +11998,7 @@
               <a:buNone/>
             </a:pPr>
             <a:r>
-              <a:rPr lang="en-US" sz="2400" b="1" dirty="0">
+              <a:rPr lang="en-US" sz="2700" b="1" dirty="0">
                 <a:solidFill>
                   <a:srgbClr val="D9534F"/>
                 </a:solidFill>
@@ -12008,7 +12008,7 @@
               </a:rPr>
               <a:t>15 Min.</a:t>
             </a:r>
-            <a:endParaRPr lang="en-US" sz="2400" dirty="0"/>
+            <a:endParaRPr lang="en-US" sz="2700" dirty="0"/>
           </a:p>
         </p:txBody>
       </p:sp>
@@ -12118,7 +12118,7 @@
               <a:buNone/>
             </a:pPr>
             <a:r>
-              <a:rPr lang="en-US" sz="2400" b="1" dirty="0">
+              <a:rPr lang="en-US" sz="2700" b="1" dirty="0">
                 <a:solidFill>
                   <a:srgbClr val="1E2761"/>
                 </a:solidFill>
@@ -12128,7 +12128,7 @@
               </a:rPr>
               <a:t>Auswerten</a:t>
             </a:r>
-            <a:endParaRPr lang="en-US" sz="2400" dirty="0"/>
+            <a:endParaRPr lang="en-US" sz="2700" dirty="0"/>
           </a:p>
         </p:txBody>
       </p:sp>
@@ -12157,7 +12157,7 @@
               <a:buNone/>
             </a:pPr>
             <a:r>
-              <a:rPr lang="en-US" sz="2400" dirty="0">
+              <a:rPr lang="en-US" sz="2700" dirty="0">
                 <a:solidFill>
                   <a:srgbClr val="5B6B8C"/>
                 </a:solidFill>
@@ -12167,7 +12167,7 @@
               </a:rPr>
               <a:t>Berater-Frage</a:t>
             </a:r>
-            <a:endParaRPr lang="en-US" sz="2400" dirty="0"/>
+            <a:endParaRPr lang="en-US" sz="2700" dirty="0"/>
           </a:p>
         </p:txBody>
       </p:sp>
@@ -12196,7 +12196,7 @@
               <a:buNone/>
             </a:pPr>
             <a:r>
-              <a:rPr lang="en-US" sz="2400" b="1" dirty="0">
+              <a:rPr lang="en-US" sz="2700" b="1" dirty="0">
                 <a:solidFill>
                   <a:srgbClr val="D9534F"/>
                 </a:solidFill>
@@ -12206,7 +12206,7 @@
               </a:rPr>
               <a:t>6 Min.</a:t>
             </a:r>
-            <a:endParaRPr lang="en-US" sz="2400" dirty="0"/>
+            <a:endParaRPr lang="en-US" sz="2700" dirty="0"/>
           </a:p>
         </p:txBody>
       </p:sp>
@@ -12257,7 +12257,7 @@
               <a:buNone/>
             </a:pPr>
             <a:r>
-              <a:rPr lang="en-US" sz="2400" b="1" dirty="0">
+              <a:rPr lang="en-US" sz="2700" b="1" dirty="0">
                 <a:solidFill>
                   <a:srgbClr val="FFFFFF"/>
                 </a:solidFill>
@@ -12271,7 +12271,7 @@
               <a:buNone/>
             </a:pPr>
             <a:r>
-              <a:rPr lang="en-US" sz="2400" dirty="0">
+              <a:rPr lang="en-US" sz="2700" dirty="0">
                 <a:solidFill>
                   <a:srgbClr val="FFFFFF"/>
                 </a:solidFill>
@@ -12279,9 +12279,9 @@
                 <a:ea typeface="Calibri" pitchFamily="34" charset="-122"/>
                 <a:cs typeface="Calibri" pitchFamily="34" charset="-120"/>
               </a:rPr>
-              <a:t>Wir arbeiten konzentriert. Gesprochen wird, wenn es auf der Folie steht.</a:t>
-            </a:r>
-            <a:endParaRPr lang="en-US" sz="2400" dirty="0"/>
+              <a:t>Wir arbeiten konzentriert. Gesprochen wird nach Ansage.</a:t>
+            </a:r>
+            <a:endParaRPr lang="en-US" sz="2700" dirty="0"/>
           </a:p>
         </p:txBody>
       </p:sp>
@@ -12874,7 +12874,7 @@
               <a:buNone/>
             </a:pPr>
             <a:r>
-              <a:rPr lang="en-US" sz="2400" dirty="0">
+              <a:rPr lang="en-US" sz="2700" dirty="0">
                 <a:solidFill>
                   <a:srgbClr val="1E2761"/>
                 </a:solidFill>
@@ -12884,7 +12884,7 @@
               </a:rPr>
               <a:t>Bei den Generalständen hat jeder Abgeordnete eine Stimme.</a:t>
             </a:r>
-            <a:endParaRPr lang="en-US" sz="2400" dirty="0"/>
+            <a:endParaRPr lang="en-US" sz="2700" dirty="0"/>
           </a:p>
         </p:txBody>
       </p:sp>
@@ -12972,7 +12972,7 @@
               <a:buNone/>
             </a:pPr>
             <a:r>
-              <a:rPr lang="en-US" sz="2400" dirty="0">
+              <a:rPr lang="en-US" sz="2700" dirty="0">
                 <a:solidFill>
                   <a:srgbClr val="1E2761"/>
                 </a:solidFill>
@@ -12982,7 +12982,7 @@
               </a:rPr>
               <a:t>Klerus und Adel haben zusammen zwei von drei Stimmen.</a:t>
             </a:r>
-            <a:endParaRPr lang="en-US" sz="2400" dirty="0"/>
+            <a:endParaRPr lang="en-US" sz="2700" dirty="0"/>
           </a:p>
         </p:txBody>
       </p:sp>
@@ -13070,7 +13070,7 @@
               <a:buNone/>
             </a:pPr>
             <a:r>
-              <a:rPr lang="en-US" sz="2400" dirty="0">
+              <a:rPr lang="en-US" sz="2700" dirty="0">
                 <a:solidFill>
                   <a:srgbClr val="1E2761"/>
                 </a:solidFill>
@@ -13080,7 +13080,7 @@
               </a:rPr>
               <a:t>Der Dritte Stand (Bauern und Bürger) stellt etwa 3 % der Menschen.</a:t>
             </a:r>
-            <a:endParaRPr lang="en-US" sz="2400" dirty="0"/>
+            <a:endParaRPr lang="en-US" sz="2700" dirty="0"/>
           </a:p>
         </p:txBody>
       </p:sp>
@@ -13168,7 +13168,7 @@
               <a:buNone/>
             </a:pPr>
             <a:r>
-              <a:rPr lang="en-US" sz="2400" dirty="0">
+              <a:rPr lang="en-US" sz="2700" dirty="0">
                 <a:solidFill>
                   <a:srgbClr val="1E2761"/>
                 </a:solidFill>
@@ -13178,7 +13178,7 @@
               </a:rPr>
               <a:t>Bei der Abstimmung nach Köpfen hätte er weniger Gewicht gehabt.</a:t>
             </a:r>
-            <a:endParaRPr lang="en-US" sz="2400" dirty="0"/>
+            <a:endParaRPr lang="en-US" sz="2700" dirty="0"/>
           </a:p>
         </p:txBody>
       </p:sp>
@@ -13266,7 +13266,7 @@
               <a:buNone/>
             </a:pPr>
             <a:r>
-              <a:rPr lang="en-US" sz="2400" dirty="0">
+              <a:rPr lang="en-US" sz="2700" dirty="0">
                 <a:solidFill>
                   <a:srgbClr val="1E2761"/>
                 </a:solidFill>
@@ -13276,7 +13276,7 @@
               </a:rPr>
               <a:t>Der König erlaubte die Abstimmung nach Köpfen.</a:t>
             </a:r>
-            <a:endParaRPr lang="en-US" sz="2400" dirty="0"/>
+            <a:endParaRPr lang="en-US" sz="2700" dirty="0"/>
           </a:p>
         </p:txBody>
       </p:sp>
@@ -13364,7 +13364,7 @@
               <a:buNone/>
             </a:pPr>
             <a:r>
-              <a:rPr lang="en-US" sz="2400" b="1" dirty="0">
+              <a:rPr lang="en-US" sz="2700" b="1" dirty="0">
                 <a:solidFill>
                   <a:srgbClr val="1E2761"/>
                 </a:solidFill>
@@ -13374,7 +13374,7 @@
               </a:rPr>
               <a:t>Vier Sätze enthalten einen Fehler. Unterstreiche die Fehler.</a:t>
             </a:r>
-            <a:endParaRPr lang="en-US" sz="2400" dirty="0"/>
+            <a:endParaRPr lang="en-US" sz="2700" dirty="0"/>
           </a:p>
         </p:txBody>
       </p:sp>
@@ -13462,7 +13462,7 @@
               <a:buNone/>
             </a:pPr>
             <a:r>
-              <a:rPr lang="en-US" sz="2400" b="1" dirty="0">
+              <a:rPr lang="en-US" sz="2700" b="1" dirty="0">
                 <a:solidFill>
                   <a:srgbClr val="1E2761"/>
                 </a:solidFill>
@@ -13472,7 +13472,7 @@
               </a:rPr>
               <a:t>Schreibe diese Sätze richtig ins Heft.</a:t>
             </a:r>
-            <a:endParaRPr lang="en-US" sz="2400" dirty="0"/>
+            <a:endParaRPr lang="en-US" sz="2700" dirty="0"/>
           </a:p>
         </p:txBody>
       </p:sp>
@@ -13523,7 +13523,7 @@
               <a:buNone/>
             </a:pPr>
             <a:r>
-              <a:rPr lang="en-US" sz="2400" b="1" dirty="0">
+              <a:rPr lang="en-US" sz="2700" b="1" dirty="0">
                 <a:solidFill>
                   <a:srgbClr val="FFFFFF"/>
                 </a:solidFill>
@@ -13537,7 +13537,7 @@
               <a:buNone/>
             </a:pPr>
             <a:r>
-              <a:rPr lang="en-US" sz="2400" dirty="0">
+              <a:rPr lang="en-US" sz="2700" dirty="0">
                 <a:solidFill>
                   <a:srgbClr val="FFFFFF"/>
                 </a:solidFill>
@@ -13551,7 +13551,7 @@
               <a:buNone/>
             </a:pPr>
             <a:r>
-              <a:rPr lang="en-US" sz="2400" i="1" dirty="0">
+              <a:rPr lang="en-US" sz="2700" i="1" dirty="0">
                 <a:solidFill>
                   <a:srgbClr val="CADCFC"/>
                 </a:solidFill>
@@ -13561,7 +13561,7 @@
               </a:rPr>
               <a:t>Fertig? Stift hinlegen.</a:t>
             </a:r>
-            <a:endParaRPr lang="en-US" sz="2400" dirty="0"/>
+            <a:endParaRPr lang="en-US" sz="2700" dirty="0"/>
           </a:p>
         </p:txBody>
       </p:sp>
@@ -14154,7 +14154,7 @@
               <a:buNone/>
             </a:pPr>
             <a:r>
-              <a:rPr lang="en-US" sz="2400" dirty="0">
+              <a:rPr lang="en-US" sz="2700" dirty="0">
                 <a:solidFill>
                   <a:srgbClr val="1E2761"/>
                 </a:solidFill>
@@ -14168,7 +14168,7 @@
               <a:buNone/>
             </a:pPr>
             <a:r>
-              <a:rPr lang="en-US" sz="2400" b="1" dirty="0">
+              <a:rPr lang="en-US" sz="2700" b="1" dirty="0">
                 <a:solidFill>
                   <a:srgbClr val="2E9E6B"/>
                 </a:solidFill>
@@ -14182,7 +14182,7 @@
               <a:buNone/>
             </a:pPr>
             <a:r>
-              <a:rPr lang="en-US" sz="2400" dirty="0">
+              <a:rPr lang="en-US" sz="2700" dirty="0">
                 <a:solidFill>
                   <a:srgbClr val="1E2761"/>
                 </a:solidFill>
@@ -14192,7 +14192,7 @@
               </a:rPr>
               <a:t> eine Stimme.</a:t>
             </a:r>
-            <a:endParaRPr lang="en-US" sz="2400" dirty="0"/>
+            <a:endParaRPr lang="en-US" sz="2700" dirty="0"/>
           </a:p>
         </p:txBody>
       </p:sp>
@@ -14280,7 +14280,7 @@
               <a:buNone/>
             </a:pPr>
             <a:r>
-              <a:rPr lang="en-US" sz="2400" dirty="0">
+              <a:rPr lang="en-US" sz="2700" dirty="0">
                 <a:solidFill>
                   <a:srgbClr val="1E2761"/>
                 </a:solidFill>
@@ -14294,7 +14294,7 @@
               <a:buNone/>
             </a:pPr>
             <a:r>
-              <a:rPr lang="en-US" sz="2400" i="1" dirty="0">
+              <a:rPr lang="en-US" sz="2700" i="1" dirty="0">
                 <a:solidFill>
                   <a:srgbClr val="5B6B8C"/>
                 </a:solidFill>
@@ -14304,7 +14304,7 @@
               </a:rPr>
               <a:t>(war richtig)</a:t>
             </a:r>
-            <a:endParaRPr lang="en-US" sz="2400" dirty="0"/>
+            <a:endParaRPr lang="en-US" sz="2700" dirty="0"/>
           </a:p>
         </p:txBody>
       </p:sp>
@@ -14392,7 +14392,7 @@
               <a:buNone/>
             </a:pPr>
             <a:r>
-              <a:rPr lang="en-US" sz="2400" dirty="0">
+              <a:rPr lang="en-US" sz="2700" dirty="0">
                 <a:solidFill>
                   <a:srgbClr val="1E2761"/>
                 </a:solidFill>
@@ -14406,7 +14406,7 @@
               <a:buNone/>
             </a:pPr>
             <a:r>
-              <a:rPr lang="en-US" sz="2400" b="1" dirty="0">
+              <a:rPr lang="en-US" sz="2700" b="1" dirty="0">
                 <a:solidFill>
                   <a:srgbClr val="2E9E6B"/>
                 </a:solidFill>
@@ -14420,7 +14420,7 @@
               <a:buNone/>
             </a:pPr>
             <a:r>
-              <a:rPr lang="en-US" sz="2400" dirty="0">
+              <a:rPr lang="en-US" sz="2700" dirty="0">
                 <a:solidFill>
                   <a:srgbClr val="1E2761"/>
                 </a:solidFill>
@@ -14430,7 +14430,7 @@
               </a:rPr>
               <a:t> der Menschen.</a:t>
             </a:r>
-            <a:endParaRPr lang="en-US" sz="2400" dirty="0"/>
+            <a:endParaRPr lang="en-US" sz="2700" dirty="0"/>
           </a:p>
         </p:txBody>
       </p:sp>
@@ -14518,7 +14518,7 @@
               <a:buNone/>
             </a:pPr>
             <a:r>
-              <a:rPr lang="en-US" sz="2400" dirty="0">
+              <a:rPr lang="en-US" sz="2700" dirty="0">
                 <a:solidFill>
                   <a:srgbClr val="1E2761"/>
                 </a:solidFill>
@@ -14532,7 +14532,7 @@
               <a:buNone/>
             </a:pPr>
             <a:r>
-              <a:rPr lang="en-US" sz="2400" b="1" dirty="0">
+              <a:rPr lang="en-US" sz="2700" b="1" dirty="0">
                 <a:solidFill>
                   <a:srgbClr val="2E9E6B"/>
                 </a:solidFill>
@@ -14546,7 +14546,7 @@
               <a:buNone/>
             </a:pPr>
             <a:r>
-              <a:rPr lang="en-US" sz="2400" dirty="0">
+              <a:rPr lang="en-US" sz="2700" dirty="0">
                 <a:solidFill>
                   <a:srgbClr val="1E2761"/>
                 </a:solidFill>
@@ -14556,7 +14556,7 @@
               </a:rPr>
               <a:t> Gewicht gehabt.</a:t>
             </a:r>
-            <a:endParaRPr lang="en-US" sz="2400" dirty="0"/>
+            <a:endParaRPr lang="en-US" sz="2700" dirty="0"/>
           </a:p>
         </p:txBody>
       </p:sp>
@@ -14644,7 +14644,7 @@
               <a:buNone/>
             </a:pPr>
             <a:r>
-              <a:rPr lang="en-US" sz="2400" dirty="0">
+              <a:rPr lang="en-US" sz="2700" dirty="0">
                 <a:solidFill>
                   <a:srgbClr val="1E2761"/>
                 </a:solidFill>
@@ -14658,7 +14658,7 @@
               <a:buNone/>
             </a:pPr>
             <a:r>
-              <a:rPr lang="en-US" sz="2400" b="1" dirty="0">
+              <a:rPr lang="en-US" sz="2700" b="1" dirty="0">
                 <a:solidFill>
                   <a:srgbClr val="2E9E6B"/>
                 </a:solidFill>
@@ -14672,7 +14672,7 @@
               <a:buNone/>
             </a:pPr>
             <a:r>
-              <a:rPr lang="en-US" sz="2400" dirty="0">
+              <a:rPr lang="en-US" sz="2700" dirty="0">
                 <a:solidFill>
                   <a:srgbClr val="1E2761"/>
                 </a:solidFill>
@@ -14686,7 +14686,7 @@
               <a:buNone/>
             </a:pPr>
             <a:r>
-              <a:rPr lang="en-US" sz="2400" b="1" dirty="0">
+              <a:rPr lang="en-US" sz="2700" b="1" dirty="0">
                 <a:solidFill>
                   <a:srgbClr val="2E9E6B"/>
                 </a:solidFill>
@@ -14700,7 +14700,7 @@
               <a:buNone/>
             </a:pPr>
             <a:r>
-              <a:rPr lang="en-US" sz="2400" dirty="0">
+              <a:rPr lang="en-US" sz="2700" dirty="0">
                 <a:solidFill>
                   <a:srgbClr val="1E2761"/>
                 </a:solidFill>
@@ -14710,7 +14710,7 @@
               </a:rPr>
               <a:t>.</a:t>
             </a:r>
-            <a:endParaRPr lang="en-US" sz="2400" dirty="0"/>
+            <a:endParaRPr lang="en-US" sz="2700" dirty="0"/>
           </a:p>
         </p:txBody>
       </p:sp>
@@ -14761,7 +14761,7 @@
               <a:buNone/>
             </a:pPr>
             <a:r>
-              <a:rPr lang="en-US" sz="2400" b="1" dirty="0">
+              <a:rPr lang="en-US" sz="2700" b="1" dirty="0">
                 <a:solidFill>
                   <a:srgbClr val="FFFFFF"/>
                 </a:solidFill>
@@ -14775,7 +14775,7 @@
               <a:buNone/>
             </a:pPr>
             <a:r>
-              <a:rPr lang="en-US" sz="2400" dirty="0">
+              <a:rPr lang="en-US" sz="2700" dirty="0">
                 <a:solidFill>
                   <a:srgbClr val="FFFFFF"/>
                 </a:solidFill>
@@ -14785,7 +14785,7 @@
               </a:rPr>
               <a:t>Vergleiche und verbessere mit Grün.</a:t>
             </a:r>
-            <a:endParaRPr lang="en-US" sz="2400" dirty="0"/>
+            <a:endParaRPr lang="en-US" sz="2700" dirty="0"/>
           </a:p>
         </p:txBody>
       </p:sp>
@@ -15358,7 +15358,7 @@
               <a:buNone/>
             </a:pPr>
             <a:r>
-              <a:rPr lang="en-US" sz="2400" dirty="0">
+              <a:rPr lang="en-US" sz="2700" dirty="0">
                 <a:solidFill>
                   <a:srgbClr val="1E2761"/>
                 </a:solidFill>
@@ -15368,7 +15368,7 @@
               </a:rPr>
               <a:t>Jeder Stand hat eine Stimme.</a:t>
             </a:r>
-            <a:endParaRPr lang="en-US" sz="2400" dirty="0"/>
+            <a:endParaRPr lang="en-US" sz="2700" dirty="0"/>
           </a:p>
         </p:txBody>
       </p:sp>
@@ -15380,8 +15380,8 @@
         </p:nvSpPr>
         <p:spPr>
           <a:xfrm>
-            <a:off x="822960" y="2743200"/>
-            <a:ext cx="1508760" cy="1097280"/>
+            <a:off x="822960" y="2606040"/>
+            <a:ext cx="1508760" cy="1463040"/>
           </a:xfrm>
           <a:prstGeom prst="rect">
             <a:avLst/>
@@ -15400,8 +15400,8 @@
         </p:nvSpPr>
         <p:spPr>
           <a:xfrm>
-            <a:off x="822960" y="2743200"/>
-            <a:ext cx="1508760" cy="1097280"/>
+            <a:off x="822960" y="2606040"/>
+            <a:ext cx="1508760" cy="1463040"/>
           </a:xfrm>
           <a:prstGeom prst="rect">
             <a:avLst/>
@@ -15417,7 +15417,7 @@
               <a:buNone/>
             </a:pPr>
             <a:r>
-              <a:rPr lang="en-US" sz="2400" b="1" dirty="0">
+              <a:rPr lang="en-US" sz="2700" b="1" dirty="0">
                 <a:solidFill>
                   <a:srgbClr val="FFFFFF"/>
                 </a:solidFill>
@@ -15427,14 +15427,14 @@
               </a:rPr>
               <a:t>Klerus</a:t>
             </a:r>
-            <a:endParaRPr lang="en-US" sz="2400" dirty="0"/>
+            <a:endParaRPr lang="en-US" sz="2700" dirty="0"/>
           </a:p>
           <a:p>
             <a:pPr algn="ctr" indent="0" marL="0">
               <a:buNone/>
             </a:pPr>
             <a:r>
-              <a:rPr lang="en-US" sz="2400" b="1" dirty="0">
+              <a:rPr lang="en-US" sz="2700" b="1" dirty="0">
                 <a:solidFill>
                   <a:srgbClr val="FFFFFF"/>
                 </a:solidFill>
@@ -15444,7 +15444,7 @@
               </a:rPr>
               <a:t>Nein</a:t>
             </a:r>
-            <a:endParaRPr lang="en-US" sz="2400" dirty="0"/>
+            <a:endParaRPr lang="en-US" sz="2700" dirty="0"/>
           </a:p>
         </p:txBody>
       </p:sp>
@@ -15456,8 +15456,8 @@
         </p:nvSpPr>
         <p:spPr>
           <a:xfrm>
-            <a:off x="2468880" y="2743200"/>
-            <a:ext cx="1508760" cy="1097280"/>
+            <a:off x="2468880" y="2606040"/>
+            <a:ext cx="1508760" cy="1463040"/>
           </a:xfrm>
           <a:prstGeom prst="rect">
             <a:avLst/>
@@ -15476,8 +15476,8 @@
         </p:nvSpPr>
         <p:spPr>
           <a:xfrm>
-            <a:off x="2468880" y="2743200"/>
-            <a:ext cx="1508760" cy="1097280"/>
+            <a:off x="2468880" y="2606040"/>
+            <a:ext cx="1508760" cy="1463040"/>
           </a:xfrm>
           <a:prstGeom prst="rect">
             <a:avLst/>
@@ -15493,7 +15493,7 @@
               <a:buNone/>
             </a:pPr>
             <a:r>
-              <a:rPr lang="en-US" sz="2400" b="1" dirty="0">
+              <a:rPr lang="en-US" sz="2700" b="1" dirty="0">
                 <a:solidFill>
                   <a:srgbClr val="FFFFFF"/>
                 </a:solidFill>
@@ -15503,14 +15503,14 @@
               </a:rPr>
               <a:t>Adel</a:t>
             </a:r>
-            <a:endParaRPr lang="en-US" sz="2400" dirty="0"/>
+            <a:endParaRPr lang="en-US" sz="2700" dirty="0"/>
           </a:p>
           <a:p>
             <a:pPr algn="ctr" indent="0" marL="0">
               <a:buNone/>
             </a:pPr>
             <a:r>
-              <a:rPr lang="en-US" sz="2400" b="1" dirty="0">
+              <a:rPr lang="en-US" sz="2700" b="1" dirty="0">
                 <a:solidFill>
                   <a:srgbClr val="FFFFFF"/>
                 </a:solidFill>
@@ -15520,7 +15520,7 @@
               </a:rPr>
               <a:t>Nein</a:t>
             </a:r>
-            <a:endParaRPr lang="en-US" sz="2400" dirty="0"/>
+            <a:endParaRPr lang="en-US" sz="2700" dirty="0"/>
           </a:p>
         </p:txBody>
       </p:sp>
@@ -15532,8 +15532,8 @@
         </p:nvSpPr>
         <p:spPr>
           <a:xfrm>
-            <a:off x="4114800" y="2743200"/>
-            <a:ext cx="1508760" cy="1097280"/>
+            <a:off x="4114800" y="2606040"/>
+            <a:ext cx="1508760" cy="1463040"/>
           </a:xfrm>
           <a:prstGeom prst="rect">
             <a:avLst/>
@@ -15552,8 +15552,8 @@
         </p:nvSpPr>
         <p:spPr>
           <a:xfrm>
-            <a:off x="4114800" y="2743200"/>
-            <a:ext cx="1508760" cy="1097280"/>
+            <a:off x="4114800" y="2606040"/>
+            <a:ext cx="1508760" cy="1463040"/>
           </a:xfrm>
           <a:prstGeom prst="rect">
             <a:avLst/>
@@ -15569,7 +15569,7 @@
               <a:buNone/>
             </a:pPr>
             <a:r>
-              <a:rPr lang="en-US" sz="2400" b="1" dirty="0">
+              <a:rPr lang="en-US" sz="2700" b="1" dirty="0">
                 <a:solidFill>
                   <a:srgbClr val="FFFFFF"/>
                 </a:solidFill>
@@ -15579,14 +15579,14 @@
               </a:rPr>
               <a:t>Dritter Stand</a:t>
             </a:r>
-            <a:endParaRPr lang="en-US" sz="2400" dirty="0"/>
+            <a:endParaRPr lang="en-US" sz="2700" dirty="0"/>
           </a:p>
           <a:p>
             <a:pPr algn="ctr" indent="0" marL="0">
               <a:buNone/>
             </a:pPr>
             <a:r>
-              <a:rPr lang="en-US" sz="2400" b="1" dirty="0">
+              <a:rPr lang="en-US" sz="2700" b="1" dirty="0">
                 <a:solidFill>
                   <a:srgbClr val="FFFFFF"/>
                 </a:solidFill>
@@ -15596,7 +15596,7 @@
               </a:rPr>
               <a:t>Ja</a:t>
             </a:r>
-            <a:endParaRPr lang="en-US" sz="2400" dirty="0"/>
+            <a:endParaRPr lang="en-US" sz="2700" dirty="0"/>
           </a:p>
         </p:txBody>
       </p:sp>
@@ -15608,7 +15608,7 @@
         </p:nvSpPr>
         <p:spPr>
           <a:xfrm>
-            <a:off x="822960" y="4114800"/>
+            <a:off x="822960" y="4343400"/>
             <a:ext cx="4937760" cy="640080"/>
           </a:xfrm>
           <a:prstGeom prst="rect">
@@ -15725,7 +15725,7 @@
               <a:buNone/>
             </a:pPr>
             <a:r>
-              <a:rPr lang="en-US" sz="2400" dirty="0">
+              <a:rPr lang="en-US" sz="2700" dirty="0">
                 <a:solidFill>
                   <a:srgbClr val="1E2761"/>
                 </a:solidFill>
@@ -15733,9 +15733,9 @@
                 <a:ea typeface="Calibri" pitchFamily="34" charset="-122"/>
                 <a:cs typeface="Calibri" pitchFamily="34" charset="-120"/>
               </a:rPr>
-              <a:t>Jeder Abgeordnete hat eine Stimme.</a:t>
-            </a:r>
-            <a:endParaRPr lang="en-US" sz="2400" dirty="0"/>
+              <a:t>Jeder Abgeordnete: eine Stimme.</a:t>
+            </a:r>
+            <a:endParaRPr lang="en-US" sz="2700" dirty="0"/>
           </a:p>
         </p:txBody>
       </p:sp>
@@ -15747,8 +15747,8 @@
         </p:nvSpPr>
         <p:spPr>
           <a:xfrm>
-            <a:off x="6492240" y="2743200"/>
-            <a:ext cx="2488933" cy="1097280"/>
+            <a:off x="6492240" y="2606040"/>
+            <a:ext cx="2488933" cy="1463040"/>
           </a:xfrm>
           <a:prstGeom prst="rect">
             <a:avLst/>
@@ -15772,8 +15772,8 @@
         </p:nvSpPr>
         <p:spPr>
           <a:xfrm>
-            <a:off x="6492240" y="2743200"/>
-            <a:ext cx="2488933" cy="1097280"/>
+            <a:off x="6492240" y="2606040"/>
+            <a:ext cx="2488933" cy="1463040"/>
           </a:xfrm>
           <a:prstGeom prst="rect">
             <a:avLst/>
@@ -15789,7 +15789,7 @@
               <a:buNone/>
             </a:pPr>
             <a:r>
-              <a:rPr lang="en-US" sz="2400" b="1" dirty="0">
+              <a:rPr lang="en-US" sz="2700" b="1" dirty="0">
                 <a:solidFill>
                   <a:srgbClr val="FFFFFF"/>
                 </a:solidFill>
@@ -15799,7 +15799,7 @@
               </a:rPr>
               <a:t>Ja 580</a:t>
             </a:r>
-            <a:endParaRPr lang="en-US" sz="2400" dirty="0"/>
+            <a:endParaRPr lang="en-US" sz="2700" dirty="0"/>
           </a:p>
         </p:txBody>
       </p:sp>
@@ -15811,8 +15811,8 @@
         </p:nvSpPr>
         <p:spPr>
           <a:xfrm>
-            <a:off x="8981173" y="2743200"/>
-            <a:ext cx="2403107" cy="1097280"/>
+            <a:off x="8981173" y="2606040"/>
+            <a:ext cx="2403107" cy="1463040"/>
           </a:xfrm>
           <a:prstGeom prst="rect">
             <a:avLst/>
@@ -15836,8 +15836,8 @@
         </p:nvSpPr>
         <p:spPr>
           <a:xfrm>
-            <a:off x="8981173" y="2743200"/>
-            <a:ext cx="2403107" cy="1097280"/>
+            <a:off x="8981173" y="2606040"/>
+            <a:ext cx="2403107" cy="1463040"/>
           </a:xfrm>
           <a:prstGeom prst="rect">
             <a:avLst/>
@@ -15853,7 +15853,7 @@
               <a:buNone/>
             </a:pPr>
             <a:r>
-              <a:rPr lang="en-US" sz="2400" b="1" dirty="0">
+              <a:rPr lang="en-US" sz="2700" b="1" dirty="0">
                 <a:solidFill>
                   <a:srgbClr val="FFFFFF"/>
                 </a:solidFill>
@@ -15863,7 +15863,7 @@
               </a:rPr>
               <a:t>Nein 560</a:t>
             </a:r>
-            <a:endParaRPr lang="en-US" sz="2400" dirty="0"/>
+            <a:endParaRPr lang="en-US" sz="2700" dirty="0"/>
           </a:p>
         </p:txBody>
       </p:sp>
@@ -15875,8 +15875,8 @@
         </p:nvSpPr>
         <p:spPr>
           <a:xfrm>
-            <a:off x="6492240" y="4114800"/>
-            <a:ext cx="4937760" cy="640080"/>
+            <a:off x="6492240" y="4343400"/>
+            <a:ext cx="4937760" cy="1005840"/>
           </a:xfrm>
           <a:prstGeom prst="rect">
             <a:avLst/>
@@ -15953,7 +15953,7 @@
               <a:buNone/>
             </a:pPr>
             <a:r>
-              <a:rPr lang="en-US" sz="2400" b="1" dirty="0">
+              <a:rPr lang="en-US" sz="2700" b="1" dirty="0">
                 <a:solidFill>
                   <a:srgbClr val="FFFFFF"/>
                 </a:solidFill>
@@ -15967,7 +15967,7 @@
               <a:buNone/>
             </a:pPr>
             <a:r>
-              <a:rPr lang="en-US" sz="2400" dirty="0">
+              <a:rPr lang="en-US" sz="2700" dirty="0">
                 <a:solidFill>
                   <a:srgbClr val="FFFFFF"/>
                 </a:solidFill>
@@ -15977,7 +15977,7 @@
               </a:rPr>
               <a:t>1789 wurde nicht nach Köpfen abgestimmt.</a:t>
             </a:r>
-            <a:endParaRPr lang="en-US" sz="2400" dirty="0"/>
+            <a:endParaRPr lang="en-US" sz="2700" dirty="0"/>
           </a:p>
         </p:txBody>
       </p:sp>
@@ -16100,11 +16100,11 @@
         <p:spPr>
           <a:xfrm>
             <a:off x="548640" y="1371600"/>
-            <a:ext cx="11109960" cy="2148840"/>
+            <a:ext cx="11109960" cy="2560320"/>
           </a:xfrm>
           <a:prstGeom prst="roundRect">
             <a:avLst>
-              <a:gd name="adj" fmla="val 3404"/>
+              <a:gd name="adj" fmla="val 2857"/>
             </a:avLst>
           </a:prstGeom>
           <a:solidFill>
@@ -16197,7 +16197,7 @@
               <a:buNone/>
             </a:pPr>
             <a:r>
-              <a:rPr lang="en-US" sz="2400" b="1" dirty="0">
+              <a:rPr lang="en-US" sz="2700" b="1" dirty="0">
                 <a:solidFill>
                   <a:srgbClr val="1E2761"/>
                 </a:solidFill>
@@ -16207,7 +16207,7 @@
               </a:rPr>
               <a:t>Lies den Text. Unterstreiche alle Daten.</a:t>
             </a:r>
-            <a:endParaRPr lang="en-US" sz="2400" dirty="0"/>
+            <a:endParaRPr lang="en-US" sz="2700" dirty="0"/>
           </a:p>
         </p:txBody>
       </p:sp>
@@ -16279,7 +16279,7 @@
         <p:spPr>
           <a:xfrm>
             <a:off x="1280160" y="2011680"/>
-            <a:ext cx="10241280" cy="457200"/>
+            <a:ext cx="10241280" cy="868680"/>
           </a:xfrm>
           <a:prstGeom prst="rect">
             <a:avLst/>
@@ -16295,7 +16295,7 @@
               <a:buNone/>
             </a:pPr>
             <a:r>
-              <a:rPr lang="en-US" sz="2400" b="1" dirty="0">
+              <a:rPr lang="en-US" sz="2700" b="1" dirty="0">
                 <a:solidFill>
                   <a:srgbClr val="1E2761"/>
                 </a:solidFill>
@@ -16305,7 +16305,7 @@
               </a:rPr>
               <a:t>Schreibe zu jedem Datum das Ereignis in den Zeitstrahl.</a:t>
             </a:r>
-            <a:endParaRPr lang="en-US" sz="2400" dirty="0"/>
+            <a:endParaRPr lang="en-US" sz="2700" dirty="0"/>
           </a:p>
         </p:txBody>
       </p:sp>
@@ -16317,7 +16317,7 @@
         </p:nvSpPr>
         <p:spPr>
           <a:xfrm>
-            <a:off x="731520" y="2578608"/>
+            <a:off x="731520" y="2990088"/>
             <a:ext cx="384048" cy="384048"/>
           </a:xfrm>
           <a:prstGeom prst="ellipse">
@@ -16337,7 +16337,7 @@
         </p:nvSpPr>
         <p:spPr>
           <a:xfrm>
-            <a:off x="731520" y="2578608"/>
+            <a:off x="731520" y="2990088"/>
             <a:ext cx="384048" cy="384048"/>
           </a:xfrm>
           <a:prstGeom prst="rect">
@@ -16376,7 +16376,7 @@
         </p:nvSpPr>
         <p:spPr>
           <a:xfrm>
-            <a:off x="1280160" y="2542032"/>
+            <a:off x="1280160" y="2953512"/>
             <a:ext cx="10241280" cy="868680"/>
           </a:xfrm>
           <a:prstGeom prst="rect">
@@ -16393,7 +16393,7 @@
               <a:buNone/>
             </a:pPr>
             <a:r>
-              <a:rPr lang="en-US" sz="2400" b="1" dirty="0">
+              <a:rPr lang="en-US" sz="2700" b="1" dirty="0">
                 <a:solidFill>
                   <a:srgbClr val="1E2761"/>
                 </a:solidFill>
@@ -16403,7 +16403,7 @@
               </a:rPr>
               <a:t>Schreibe ins Heft: Sieyès sagt, der Dritte Stand sei ALLES. Erkläre das mit einer Zahl.</a:t>
             </a:r>
-            <a:endParaRPr lang="en-US" sz="2400" dirty="0"/>
+            <a:endParaRPr lang="en-US" sz="2700" dirty="0"/>
           </a:p>
         </p:txBody>
       </p:sp>
@@ -16454,7 +16454,7 @@
               <a:buNone/>
             </a:pPr>
             <a:r>
-              <a:rPr lang="en-US" sz="2400" b="1" dirty="0">
+              <a:rPr lang="en-US" sz="2700" b="1" dirty="0">
                 <a:solidFill>
                   <a:srgbClr val="FFFFFF"/>
                 </a:solidFill>
@@ -16468,7 +16468,7 @@
               <a:buNone/>
             </a:pPr>
             <a:r>
-              <a:rPr lang="en-US" sz="2400" dirty="0">
+              <a:rPr lang="en-US" sz="2700" dirty="0">
                 <a:solidFill>
                   <a:srgbClr val="FFFFFF"/>
                 </a:solidFill>
@@ -16482,7 +16482,7 @@
               <a:buNone/>
             </a:pPr>
             <a:r>
-              <a:rPr lang="en-US" sz="2400" i="1" dirty="0">
+              <a:rPr lang="en-US" sz="2700" i="1" dirty="0">
                 <a:solidFill>
                   <a:srgbClr val="CADCFC"/>
                 </a:solidFill>
@@ -16490,9 +16490,9 @@
                 <a:ea typeface="Calibri" pitchFamily="34" charset="-122"/>
                 <a:cs typeface="Calibri" pitchFamily="34" charset="-120"/>
               </a:rPr>
-              <a:t>Fertig? Stift hinlegen und noch einmal durchlesen.</a:t>
-            </a:r>
-            <a:endParaRPr lang="en-US" sz="2400" dirty="0"/>
+              <a:t>Fertig? Stift hinlegen.</a:t>
+            </a:r>
+            <a:endParaRPr lang="en-US" sz="2700" dirty="0"/>
           </a:p>
         </p:txBody>
       </p:sp>
@@ -17419,7 +17419,7 @@
               <a:buNone/>
             </a:pPr>
             <a:r>
-              <a:rPr lang="en-US" sz="2400" b="1" dirty="0">
+              <a:rPr lang="en-US" sz="2700" b="1" dirty="0">
                 <a:solidFill>
                   <a:srgbClr val="D9534F"/>
                 </a:solidFill>
@@ -17429,7 +17429,7 @@
               </a:rPr>
               <a:t>Winter 1788/89</a:t>
             </a:r>
-            <a:endParaRPr lang="en-US" sz="2400" dirty="0"/>
+            <a:endParaRPr lang="en-US" sz="2700" dirty="0"/>
           </a:p>
         </p:txBody>
       </p:sp>
@@ -17483,7 +17483,7 @@
               <a:buNone/>
             </a:pPr>
             <a:r>
-              <a:rPr lang="en-US" sz="2400" dirty="0">
+              <a:rPr lang="en-US" sz="2700" dirty="0">
                 <a:solidFill>
                   <a:srgbClr val="1E2761"/>
                 </a:solidFill>
@@ -17493,7 +17493,7 @@
               </a:rPr>
               <a:t>Sieyès: Der Dritte Stand ist ALLES</a:t>
             </a:r>
-            <a:endParaRPr lang="en-US" sz="2400" dirty="0"/>
+            <a:endParaRPr lang="en-US" sz="2700" dirty="0"/>
           </a:p>
         </p:txBody>
       </p:sp>
@@ -17544,7 +17544,7 @@
               <a:buNone/>
             </a:pPr>
             <a:r>
-              <a:rPr lang="en-US" sz="2400" b="1" dirty="0">
+              <a:rPr lang="en-US" sz="2700" b="1" dirty="0">
                 <a:solidFill>
                   <a:srgbClr val="D9534F"/>
                 </a:solidFill>
@@ -17554,7 +17554,7 @@
               </a:rPr>
               <a:t>5. Mai 1789</a:t>
             </a:r>
-            <a:endParaRPr lang="en-US" sz="2400" dirty="0"/>
+            <a:endParaRPr lang="en-US" sz="2700" dirty="0"/>
           </a:p>
         </p:txBody>
       </p:sp>
@@ -17608,7 +17608,7 @@
               <a:buNone/>
             </a:pPr>
             <a:r>
-              <a:rPr lang="en-US" sz="2400" dirty="0">
+              <a:rPr lang="en-US" sz="2700" dirty="0">
                 <a:solidFill>
                   <a:srgbClr val="1E2761"/>
                 </a:solidFill>
@@ -17618,7 +17618,7 @@
               </a:rPr>
               <a:t>Eröffnung, Streit um die Abstimmung</a:t>
             </a:r>
-            <a:endParaRPr lang="en-US" sz="2400" dirty="0"/>
+            <a:endParaRPr lang="en-US" sz="2700" dirty="0"/>
           </a:p>
         </p:txBody>
       </p:sp>
@@ -17669,7 +17669,7 @@
               <a:buNone/>
             </a:pPr>
             <a:r>
-              <a:rPr lang="en-US" sz="2400" b="1" dirty="0">
+              <a:rPr lang="en-US" sz="2700" b="1" dirty="0">
                 <a:solidFill>
                   <a:srgbClr val="D9534F"/>
                 </a:solidFill>
@@ -17679,7 +17679,7 @@
               </a:rPr>
               <a:t>17. Juni 1789</a:t>
             </a:r>
-            <a:endParaRPr lang="en-US" sz="2400" dirty="0"/>
+            <a:endParaRPr lang="en-US" sz="2700" dirty="0"/>
           </a:p>
         </p:txBody>
       </p:sp>
@@ -17733,7 +17733,7 @@
               <a:buNone/>
             </a:pPr>
             <a:r>
-              <a:rPr lang="en-US" sz="2400" dirty="0">
+              <a:rPr lang="en-US" sz="2700" dirty="0">
                 <a:solidFill>
                   <a:srgbClr val="1E2761"/>
                 </a:solidFill>
@@ -17743,7 +17743,7 @@
               </a:rPr>
               <a:t>Nationalversammlung</a:t>
             </a:r>
-            <a:endParaRPr lang="en-US" sz="2400" dirty="0"/>
+            <a:endParaRPr lang="en-US" sz="2700" dirty="0"/>
           </a:p>
         </p:txBody>
       </p:sp>
@@ -17794,7 +17794,7 @@
               <a:buNone/>
             </a:pPr>
             <a:r>
-              <a:rPr lang="en-US" sz="2400" b="1" dirty="0">
+              <a:rPr lang="en-US" sz="2700" b="1" dirty="0">
                 <a:solidFill>
                   <a:srgbClr val="D9534F"/>
                 </a:solidFill>
@@ -17804,7 +17804,7 @@
               </a:rPr>
               <a:t>20. Juni 1789</a:t>
             </a:r>
-            <a:endParaRPr lang="en-US" sz="2400" dirty="0"/>
+            <a:endParaRPr lang="en-US" sz="2700" dirty="0"/>
           </a:p>
         </p:txBody>
       </p:sp>
@@ -17858,7 +17858,7 @@
               <a:buNone/>
             </a:pPr>
             <a:r>
-              <a:rPr lang="en-US" sz="2400" dirty="0">
+              <a:rPr lang="en-US" sz="2700" dirty="0">
                 <a:solidFill>
                   <a:srgbClr val="1E2761"/>
                 </a:solidFill>
@@ -17868,7 +17868,7 @@
               </a:rPr>
               <a:t>Ballhausschwur</a:t>
             </a:r>
-            <a:endParaRPr lang="en-US" sz="2400" dirty="0"/>
+            <a:endParaRPr lang="en-US" sz="2700" dirty="0"/>
           </a:p>
         </p:txBody>
       </p:sp>
@@ -17919,7 +17919,7 @@
               <a:buNone/>
             </a:pPr>
             <a:r>
-              <a:rPr lang="en-US" sz="2400" b="1" dirty="0">
+              <a:rPr lang="en-US" sz="2700" b="1" dirty="0">
                 <a:solidFill>
                   <a:srgbClr val="D9534F"/>
                 </a:solidFill>
@@ -17929,7 +17929,7 @@
               </a:rPr>
               <a:t>Anfang Juli 1789</a:t>
             </a:r>
-            <a:endParaRPr lang="en-US" sz="2400" dirty="0"/>
+            <a:endParaRPr lang="en-US" sz="2700" dirty="0"/>
           </a:p>
         </p:txBody>
       </p:sp>
@@ -17983,7 +17983,7 @@
               <a:buNone/>
             </a:pPr>
             <a:r>
-              <a:rPr lang="en-US" sz="2400" dirty="0">
+              <a:rPr lang="en-US" sz="2700" dirty="0">
                 <a:solidFill>
                   <a:srgbClr val="1E2761"/>
                 </a:solidFill>
@@ -17993,7 +17993,7 @@
               </a:rPr>
               <a:t>Soldaten um Paris, Angst in Paris</a:t>
             </a:r>
-            <a:endParaRPr lang="en-US" sz="2400" dirty="0"/>
+            <a:endParaRPr lang="en-US" sz="2700" dirty="0"/>
           </a:p>
         </p:txBody>
       </p:sp>
@@ -18551,7 +18551,7 @@
               <a:buNone/>
             </a:pPr>
             <a:r>
-              <a:rPr lang="en-US" sz="2400" b="1" dirty="0">
+              <a:rPr lang="en-US" sz="2700" b="1" dirty="0">
                 <a:solidFill>
                   <a:srgbClr val="1E2761"/>
                 </a:solidFill>
@@ -18559,9 +18559,9 @@
                 <a:ea typeface="Cambria" pitchFamily="34" charset="-122"/>
                 <a:cs typeface="Cambria" pitchFamily="34" charset="-120"/>
               </a:rPr>
-              <a:t>Zeichnung von Jacques-Louis David, 1791</a:t>
-            </a:r>
-            <a:endParaRPr lang="en-US" sz="2400" dirty="0"/>
+              <a:t>Zeichnung von David, 1791</a:t>
+            </a:r>
+            <a:endParaRPr lang="en-US" sz="2700" dirty="0"/>
           </a:p>
         </p:txBody>
       </p:sp>
@@ -18573,7 +18573,7 @@
         </p:nvSpPr>
         <p:spPr>
           <a:xfrm>
-            <a:off x="8046720" y="2468880"/>
+            <a:off x="8046720" y="2560320"/>
             <a:ext cx="3474720" cy="2926080"/>
           </a:xfrm>
           <a:prstGeom prst="rect">
@@ -18590,7 +18590,7 @@
               <a:buNone/>
             </a:pPr>
             <a:r>
-              <a:rPr lang="en-US" sz="2400" dirty="0">
+              <a:rPr lang="en-US" sz="2700" dirty="0">
                 <a:solidFill>
                   <a:srgbClr val="1E2761"/>
                 </a:solidFill>
@@ -18600,7 +18600,7 @@
               </a:rPr>
               <a:t>Die Abgeordneten schwören: Wir gehen nicht auseinander, bis Frankreich eine Verfassung hat.</a:t>
             </a:r>
-            <a:endParaRPr lang="en-US" sz="2400" dirty="0"/>
+            <a:endParaRPr lang="en-US" sz="2700" dirty="0"/>
           </a:p>
         </p:txBody>
       </p:sp>

</xml_diff>